<commit_message>
Stop the 0923 progress slides from overlapping.
Each point now sits in its own card, sized from the wrapped line count,
and the piping rules are on a separate slide so nothing runs into the footer.

Co-authored-by: peterli0913 <peterli0913@users.noreply.github.com>
</commit_message>
<xml_diff>
--- a/Progress_Report_0923.pptx
+++ b/Progress_Report_0923.pptx
@@ -9,6 +9,7 @@
     <p:sldId id="257" r:id="rId8"/>
     <p:sldId id="258" r:id="rId9"/>
     <p:sldId id="259" r:id="rId10"/>
+    <p:sldId id="260" r:id="rId11"/>
   </p:sldIdLst>
   <p:sldSz cx="12191695" cy="6858000" type="screen4x3"/>
   <p:notesSz cx="6858000" cy="9144000"/>
@@ -3313,14 +3314,104 @@
       </p:sp>
       <p:sp>
         <p:nvSpPr>
-          <p:cNvPr id="7" name="TextBox 6"/>
+          <p:cNvPr id="7" name="Rounded Rectangle 6"/>
+          <p:cNvSpPr/>
+          <p:nvPr/>
+        </p:nvSpPr>
+        <p:spPr>
+          <a:xfrm>
+            <a:off x="502920" y="1499616"/>
+            <a:ext cx="11183112" cy="703326"/>
+          </a:xfrm>
+          <a:prstGeom prst="roundRect">
+            <a:avLst/>
+          </a:prstGeom>
+          <a:solidFill>
+            <a:srgbClr val="F4F7FB"/>
+          </a:solidFill>
+          <a:ln w="12700">
+            <a:solidFill>
+              <a:srgbClr val="E3E8F0"/>
+            </a:solidFill>
+          </a:ln>
+          <a:effectLst/>
+        </p:spPr>
+        <p:style>
+          <a:lnRef idx="1">
+            <a:schemeClr val="accent1"/>
+          </a:lnRef>
+          <a:fillRef idx="3">
+            <a:schemeClr val="accent1"/>
+          </a:fillRef>
+          <a:effectRef idx="2">
+            <a:schemeClr val="accent1"/>
+          </a:effectRef>
+          <a:fontRef idx="minor">
+            <a:schemeClr val="lt1"/>
+          </a:fontRef>
+        </p:style>
+        <p:txBody>
+          <a:bodyPr rtlCol="0" anchor="ctr"/>
+          <a:lstStyle/>
+          <a:p>
+            <a:pPr algn="ctr"/>
+          </a:p>
+        </p:txBody>
+      </p:sp>
+      <p:sp>
+        <p:nvSpPr>
+          <p:cNvPr id="8" name="Rectangle 7"/>
+          <p:cNvSpPr/>
+          <p:nvPr/>
+        </p:nvSpPr>
+        <p:spPr>
+          <a:xfrm>
+            <a:off x="502920" y="1499616"/>
+            <a:ext cx="64008" cy="703326"/>
+          </a:xfrm>
+          <a:prstGeom prst="rect">
+            <a:avLst/>
+          </a:prstGeom>
+          <a:solidFill>
+            <a:srgbClr val="2563EB"/>
+          </a:solidFill>
+          <a:ln>
+            <a:noFill/>
+          </a:ln>
+          <a:effectLst/>
+        </p:spPr>
+        <p:style>
+          <a:lnRef idx="1">
+            <a:schemeClr val="accent1"/>
+          </a:lnRef>
+          <a:fillRef idx="3">
+            <a:schemeClr val="accent1"/>
+          </a:fillRef>
+          <a:effectRef idx="2">
+            <a:schemeClr val="accent1"/>
+          </a:effectRef>
+          <a:fontRef idx="minor">
+            <a:schemeClr val="lt1"/>
+          </a:fontRef>
+        </p:style>
+        <p:txBody>
+          <a:bodyPr rtlCol="0" anchor="ctr"/>
+          <a:lstStyle/>
+          <a:p>
+            <a:pPr algn="ctr"/>
+          </a:p>
+        </p:txBody>
+      </p:sp>
+      <p:sp>
+        <p:nvSpPr>
+          <p:cNvPr id="9" name="TextBox 8"/>
           <p:cNvSpPr txBox="1"/>
           <p:nvPr/>
         </p:nvSpPr>
         <p:spPr>
           <a:xfrm>
-            <a:off x="566928" y="1499616"/>
-            <a:ext cx="11064240" cy="438912"/>
+            <a:off x="749808" y="1554480"/>
+            <a:ext cx="10744200" cy="611886"/>
           </a:xfrm>
           <a:prstGeom prst="rect">
             <a:avLst/>
@@ -3328,30 +3419,342 @@
           <a:noFill/>
         </p:spPr>
         <p:txBody>
-          <a:bodyPr wrap="square" lIns="0" rIns="0">
-            <a:spAutoFit/>
-          </a:bodyPr>
-          <a:lstStyle/>
-          <a:p>
-            <a:r>
-              <a:rPr sz="1600" b="1" i="0">
-                <a:solidFill>
-                  <a:srgbClr val="2563EB"/>
+          <a:bodyPr wrap="square" lIns="0" rIns="0" tIns="0" bIns="0"/>
+          <a:lstStyle/>
+          <a:p>
+            <a:r>
+              <a:rPr sz="1500" b="1" i="0">
+                <a:solidFill>
+                  <a:srgbClr val="1E2B3A"/>
                 </a:solidFill>
                 <a:latin typeface="Segoe UI"/>
                 <a:ea typeface="Microsoft YaHei"/>
               </a:rPr>
-              <a:t>●  </a:t>
-            </a:r>
-            <a:r>
-              <a:rPr sz="1600" b="1" i="0">
+              <a:t>21 Sep — first 3D on the 8 Sep direction, issued by email.  22 Sep — reviewed live with Keith.</a:t>
+            </a:r>
+          </a:p>
+          <a:p>
+            <a:pPr>
+              <a:spcBef>
+                <a:spcPts val="300"/>
+              </a:spcBef>
+            </a:pPr>
+            <a:r>
+              <a:rPr sz="1200" b="0" i="0">
+                <a:solidFill>
+                  <a:srgbClr val="8A97AB"/>
+                </a:solidFill>
+                <a:latin typeface="Microsoft YaHei"/>
+                <a:ea typeface="Microsoft YaHei"/>
+              </a:rPr>
+              <a:t>9 月 21 日发出按 9 月 8 日方向排的第一版 3D；9 月 22 日与 Keith 对照模型过完。</a:t>
+            </a:r>
+          </a:p>
+        </p:txBody>
+      </p:sp>
+      <p:sp>
+        <p:nvSpPr>
+          <p:cNvPr id="10" name="Rounded Rectangle 9"/>
+          <p:cNvSpPr/>
+          <p:nvPr/>
+        </p:nvSpPr>
+        <p:spPr>
+          <a:xfrm>
+            <a:off x="502920" y="2312670"/>
+            <a:ext cx="11183112" cy="935736"/>
+          </a:xfrm>
+          <a:prstGeom prst="roundRect">
+            <a:avLst/>
+          </a:prstGeom>
+          <a:solidFill>
+            <a:srgbClr val="F4F7FB"/>
+          </a:solidFill>
+          <a:ln w="12700">
+            <a:solidFill>
+              <a:srgbClr val="E3E8F0"/>
+            </a:solidFill>
+          </a:ln>
+          <a:effectLst/>
+        </p:spPr>
+        <p:style>
+          <a:lnRef idx="1">
+            <a:schemeClr val="accent1"/>
+          </a:lnRef>
+          <a:fillRef idx="3">
+            <a:schemeClr val="accent1"/>
+          </a:fillRef>
+          <a:effectRef idx="2">
+            <a:schemeClr val="accent1"/>
+          </a:effectRef>
+          <a:fontRef idx="minor">
+            <a:schemeClr val="lt1"/>
+          </a:fontRef>
+        </p:style>
+        <p:txBody>
+          <a:bodyPr rtlCol="0" anchor="ctr"/>
+          <a:lstStyle/>
+          <a:p>
+            <a:pPr algn="ctr"/>
+          </a:p>
+        </p:txBody>
+      </p:sp>
+      <p:sp>
+        <p:nvSpPr>
+          <p:cNvPr id="11" name="Rectangle 10"/>
+          <p:cNvSpPr/>
+          <p:nvPr/>
+        </p:nvSpPr>
+        <p:spPr>
+          <a:xfrm>
+            <a:off x="502920" y="2312670"/>
+            <a:ext cx="64008" cy="935736"/>
+          </a:xfrm>
+          <a:prstGeom prst="rect">
+            <a:avLst/>
+          </a:prstGeom>
+          <a:solidFill>
+            <a:srgbClr val="2563EB"/>
+          </a:solidFill>
+          <a:ln>
+            <a:noFill/>
+          </a:ln>
+          <a:effectLst/>
+        </p:spPr>
+        <p:style>
+          <a:lnRef idx="1">
+            <a:schemeClr val="accent1"/>
+          </a:lnRef>
+          <a:fillRef idx="3">
+            <a:schemeClr val="accent1"/>
+          </a:fillRef>
+          <a:effectRef idx="2">
+            <a:schemeClr val="accent1"/>
+          </a:effectRef>
+          <a:fontRef idx="minor">
+            <a:schemeClr val="lt1"/>
+          </a:fontRef>
+        </p:style>
+        <p:txBody>
+          <a:bodyPr rtlCol="0" anchor="ctr"/>
+          <a:lstStyle/>
+          <a:p>
+            <a:pPr algn="ctr"/>
+          </a:p>
+        </p:txBody>
+      </p:sp>
+      <p:sp>
+        <p:nvSpPr>
+          <p:cNvPr id="12" name="TextBox 11"/>
+          <p:cNvSpPr txBox="1"/>
+          <p:nvPr/>
+        </p:nvSpPr>
+        <p:spPr>
+          <a:xfrm>
+            <a:off x="749808" y="2367534"/>
+            <a:ext cx="10744200" cy="844296"/>
+          </a:xfrm>
+          <a:prstGeom prst="rect">
+            <a:avLst/>
+          </a:prstGeom>
+          <a:noFill/>
+        </p:spPr>
+        <p:txBody>
+          <a:bodyPr wrap="square" lIns="0" rIns="0" tIns="0" bIns="0"/>
+          <a:lstStyle/>
+          <a:p>
+            <a:r>
+              <a:rPr sz="1500" b="1" i="0">
                 <a:solidFill>
                   <a:srgbClr val="1E2B3A"/>
                 </a:solidFill>
                 <a:latin typeface="Segoe UI"/>
                 <a:ea typeface="Microsoft YaHei"/>
               </a:rPr>
-              <a:t>21 Sep — first 3D on the 8 Sep direction, issued by email.  22 Sep — reviewed live with Keith.</a:t>
+              <a:t>The maintenance principle is unchanged: pull the front module out.  No central walkway.  Shipping height stays 2.5 m.</a:t>
+            </a:r>
+          </a:p>
+          <a:p>
+            <a:pPr>
+              <a:spcBef>
+                <a:spcPts val="300"/>
+              </a:spcBef>
+            </a:pPr>
+            <a:r>
+              <a:rPr sz="1200" b="0" i="0">
+                <a:solidFill>
+                  <a:srgbClr val="8A97AB"/>
+                </a:solidFill>
+                <a:latin typeface="Microsoft YaHei"/>
+                <a:ea typeface="Microsoft YaHei"/>
+              </a:rPr>
+              <a:t>维护原则未变：前撬拉出检修，不留中间通道，运输高度仍为 2.5 m。</a:t>
+            </a:r>
+          </a:p>
+        </p:txBody>
+      </p:sp>
+      <p:sp>
+        <p:nvSpPr>
+          <p:cNvPr id="13" name="Rounded Rectangle 12"/>
+          <p:cNvSpPr/>
+          <p:nvPr/>
+        </p:nvSpPr>
+        <p:spPr>
+          <a:xfrm>
+            <a:off x="502920" y="3358134"/>
+            <a:ext cx="11183112" cy="1192784"/>
+          </a:xfrm>
+          <a:prstGeom prst="roundRect">
+            <a:avLst/>
+          </a:prstGeom>
+          <a:solidFill>
+            <a:srgbClr val="F4F7FB"/>
+          </a:solidFill>
+          <a:ln w="12700">
+            <a:solidFill>
+              <a:srgbClr val="E3E8F0"/>
+            </a:solidFill>
+          </a:ln>
+          <a:effectLst/>
+        </p:spPr>
+        <p:style>
+          <a:lnRef idx="1">
+            <a:schemeClr val="accent1"/>
+          </a:lnRef>
+          <a:fillRef idx="3">
+            <a:schemeClr val="accent1"/>
+          </a:fillRef>
+          <a:effectRef idx="2">
+            <a:schemeClr val="accent1"/>
+          </a:effectRef>
+          <a:fontRef idx="minor">
+            <a:schemeClr val="lt1"/>
+          </a:fontRef>
+        </p:style>
+        <p:txBody>
+          <a:bodyPr rtlCol="0" anchor="ctr"/>
+          <a:lstStyle/>
+          <a:p>
+            <a:pPr algn="ctr"/>
+          </a:p>
+        </p:txBody>
+      </p:sp>
+      <p:sp>
+        <p:nvSpPr>
+          <p:cNvPr id="14" name="Rectangle 13"/>
+          <p:cNvSpPr/>
+          <p:nvPr/>
+        </p:nvSpPr>
+        <p:spPr>
+          <a:xfrm>
+            <a:off x="502920" y="3358134"/>
+            <a:ext cx="64008" cy="1192784"/>
+          </a:xfrm>
+          <a:prstGeom prst="rect">
+            <a:avLst/>
+          </a:prstGeom>
+          <a:solidFill>
+            <a:srgbClr val="2563EB"/>
+          </a:solidFill>
+          <a:ln>
+            <a:noFill/>
+          </a:ln>
+          <a:effectLst/>
+        </p:spPr>
+        <p:style>
+          <a:lnRef idx="1">
+            <a:schemeClr val="accent1"/>
+          </a:lnRef>
+          <a:fillRef idx="3">
+            <a:schemeClr val="accent1"/>
+          </a:fillRef>
+          <a:effectRef idx="2">
+            <a:schemeClr val="accent1"/>
+          </a:effectRef>
+          <a:fontRef idx="minor">
+            <a:schemeClr val="lt1"/>
+          </a:fontRef>
+        </p:style>
+        <p:txBody>
+          <a:bodyPr rtlCol="0" anchor="ctr"/>
+          <a:lstStyle/>
+          <a:p>
+            <a:pPr algn="ctr"/>
+          </a:p>
+        </p:txBody>
+      </p:sp>
+      <p:sp>
+        <p:nvSpPr>
+          <p:cNvPr id="15" name="TextBox 14"/>
+          <p:cNvSpPr txBox="1"/>
+          <p:nvPr/>
+        </p:nvSpPr>
+        <p:spPr>
+          <a:xfrm>
+            <a:off x="749808" y="3412998"/>
+            <a:ext cx="10744200" cy="1101344"/>
+          </a:xfrm>
+          <a:prstGeom prst="rect">
+            <a:avLst/>
+          </a:prstGeom>
+          <a:noFill/>
+        </p:spPr>
+        <p:txBody>
+          <a:bodyPr wrap="square" lIns="0" rIns="0" tIns="0" bIns="0"/>
+          <a:lstStyle/>
+          <a:p>
+            <a:r>
+              <a:rPr sz="1500" b="1" i="0">
+                <a:solidFill>
+                  <a:srgbClr val="1E2B3A"/>
+                </a:solidFill>
+                <a:latin typeface="Segoe UI"/>
+                <a:ea typeface="Microsoft YaHei"/>
+              </a:rPr>
+              <a:t>Tracker: 62 closed, 44 pending, 29 open.  Nothing moved to closed this fortnight.</a:t>
+            </a:r>
+          </a:p>
+          <a:p>
+            <a:pPr>
+              <a:spcBef>
+                <a:spcPts val="300"/>
+              </a:spcBef>
+            </a:pPr>
+            <a:r>
+              <a:rPr sz="1200" b="0" i="0">
+                <a:solidFill>
+                  <a:srgbClr val="8A97AB"/>
+                </a:solidFill>
+                <a:latin typeface="Microsoft YaHei"/>
+                <a:ea typeface="Microsoft YaHei"/>
+              </a:rPr>
+              <a:t>跟踪表：已关闭 62，待定 44，未关闭 29。本双周没有新的关闭项。</a:t>
+            </a:r>
+          </a:p>
+          <a:p>
+            <a:pPr>
+              <a:spcBef>
+                <a:spcPts val="600"/>
+              </a:spcBef>
+            </a:pPr>
+            <a:r>
+              <a:rPr sz="1300" b="0" i="0">
+                <a:solidFill>
+                  <a:srgbClr val="94A3B8"/>
+                </a:solidFill>
+                <a:latin typeface="Segoe UI"/>
+                <a:ea typeface="Microsoft YaHei"/>
+              </a:rPr>
+              <a:t>–  </a:t>
+            </a:r>
+            <a:r>
+              <a:rPr sz="1300" b="0" i="0">
+                <a:solidFill>
+                  <a:srgbClr val="3C4A5A"/>
+                </a:solidFill>
+                <a:latin typeface="Segoe UI"/>
+                <a:ea typeface="Microsoft YaHei"/>
+              </a:rPr>
+              <a:t>The movement is on the model and on three rules Keith set on 22 Sep — not on line-by-line closure.</a:t>
             </a:r>
           </a:p>
           <a:p>
@@ -3361,28 +3764,118 @@
               </a:spcBef>
             </a:pPr>
             <a:r>
-              <a:rPr sz="1150" b="0" i="0">
+              <a:rPr sz="1200" b="0" i="0">
                 <a:solidFill>
                   <a:srgbClr val="8A97AB"/>
                 </a:solidFill>
                 <a:latin typeface="Microsoft YaHei"/>
                 <a:ea typeface="Microsoft YaHei"/>
               </a:rPr>
-              <a:t>     9 月 21 日发出按 9 月 8 日方向排的第一版 3D；9 月 22 日与 Keith 对照模型过完。</a:t>
-            </a:r>
-          </a:p>
-        </p:txBody>
-      </p:sp>
-      <p:sp>
-        <p:nvSpPr>
-          <p:cNvPr id="8" name="TextBox 7"/>
+              <a:t>本期推进在模型和 22 日 Keith 定下的三条规则上，不在逐条关项上。</a:t>
+            </a:r>
+          </a:p>
+        </p:txBody>
+      </p:sp>
+      <p:sp>
+        <p:nvSpPr>
+          <p:cNvPr id="16" name="Rounded Rectangle 15"/>
+          <p:cNvSpPr/>
+          <p:nvPr/>
+        </p:nvSpPr>
+        <p:spPr>
+          <a:xfrm>
+            <a:off x="502920" y="4660646"/>
+            <a:ext cx="11183112" cy="935736"/>
+          </a:xfrm>
+          <a:prstGeom prst="roundRect">
+            <a:avLst/>
+          </a:prstGeom>
+          <a:solidFill>
+            <a:srgbClr val="F4F7FB"/>
+          </a:solidFill>
+          <a:ln w="12700">
+            <a:solidFill>
+              <a:srgbClr val="E3E8F0"/>
+            </a:solidFill>
+          </a:ln>
+          <a:effectLst/>
+        </p:spPr>
+        <p:style>
+          <a:lnRef idx="1">
+            <a:schemeClr val="accent1"/>
+          </a:lnRef>
+          <a:fillRef idx="3">
+            <a:schemeClr val="accent1"/>
+          </a:fillRef>
+          <a:effectRef idx="2">
+            <a:schemeClr val="accent1"/>
+          </a:effectRef>
+          <a:fontRef idx="minor">
+            <a:schemeClr val="lt1"/>
+          </a:fontRef>
+        </p:style>
+        <p:txBody>
+          <a:bodyPr rtlCol="0" anchor="ctr"/>
+          <a:lstStyle/>
+          <a:p>
+            <a:pPr algn="ctr"/>
+          </a:p>
+        </p:txBody>
+      </p:sp>
+      <p:sp>
+        <p:nvSpPr>
+          <p:cNvPr id="17" name="Rectangle 16"/>
+          <p:cNvSpPr/>
+          <p:nvPr/>
+        </p:nvSpPr>
+        <p:spPr>
+          <a:xfrm>
+            <a:off x="502920" y="4660646"/>
+            <a:ext cx="64008" cy="935736"/>
+          </a:xfrm>
+          <a:prstGeom prst="rect">
+            <a:avLst/>
+          </a:prstGeom>
+          <a:solidFill>
+            <a:srgbClr val="2563EB"/>
+          </a:solidFill>
+          <a:ln>
+            <a:noFill/>
+          </a:ln>
+          <a:effectLst/>
+        </p:spPr>
+        <p:style>
+          <a:lnRef idx="1">
+            <a:schemeClr val="accent1"/>
+          </a:lnRef>
+          <a:fillRef idx="3">
+            <a:schemeClr val="accent1"/>
+          </a:fillRef>
+          <a:effectRef idx="2">
+            <a:schemeClr val="accent1"/>
+          </a:effectRef>
+          <a:fontRef idx="minor">
+            <a:schemeClr val="lt1"/>
+          </a:fontRef>
+        </p:style>
+        <p:txBody>
+          <a:bodyPr rtlCol="0" anchor="ctr"/>
+          <a:lstStyle/>
+          <a:p>
+            <a:pPr algn="ctr"/>
+          </a:p>
+        </p:txBody>
+      </p:sp>
+      <p:sp>
+        <p:nvSpPr>
+          <p:cNvPr id="18" name="TextBox 17"/>
           <p:cNvSpPr txBox="1"/>
           <p:nvPr/>
         </p:nvSpPr>
         <p:spPr>
           <a:xfrm>
-            <a:off x="566928" y="2029968"/>
-            <a:ext cx="11064240" cy="438912"/>
+            <a:off x="749808" y="4715510"/>
+            <a:ext cx="10744200" cy="844296"/>
           </a:xfrm>
           <a:prstGeom prst="rect">
             <a:avLst/>
@@ -3390,217 +3883,42 @@
           <a:noFill/>
         </p:spPr>
         <p:txBody>
-          <a:bodyPr wrap="square" lIns="0" rIns="0">
-            <a:spAutoFit/>
-          </a:bodyPr>
-          <a:lstStyle/>
-          <a:p>
-            <a:r>
-              <a:rPr sz="1600" b="1" i="0">
-                <a:solidFill>
-                  <a:srgbClr val="2563EB"/>
+          <a:bodyPr wrap="square" lIns="0" rIns="0" tIns="0" bIns="0"/>
+          <a:lstStyle/>
+          <a:p>
+            <a:r>
+              <a:rPr sz="1500" b="1" i="0">
+                <a:solidFill>
+                  <a:srgbClr val="1E2B3A"/>
                 </a:solidFill>
                 <a:latin typeface="Segoe UI"/>
                 <a:ea typeface="Microsoft YaHei"/>
               </a:rPr>
-              <a:t>●  </a:t>
-            </a:r>
-            <a:r>
-              <a:rPr sz="1600" b="1" i="0">
-                <a:solidFill>
-                  <a:srgbClr val="1E2B3A"/>
-                </a:solidFill>
-                <a:latin typeface="Segoe UI"/>
-                <a:ea typeface="Microsoft YaHei"/>
-              </a:rPr>
-              <a:t>The maintenance principle is unchanged: pull the front module out.  No central walkway.  Shipping height stays 2.5 m.</a:t>
+              <a:t>Critical path has narrowed: nozzle direction and the HTF runs, then Keith can release the 18 Aug equipment drawings.</a:t>
             </a:r>
           </a:p>
           <a:p>
             <a:pPr>
               <a:spcBef>
-                <a:spcPts val="100"/>
+                <a:spcPts val="300"/>
               </a:spcBef>
             </a:pPr>
             <a:r>
-              <a:rPr sz="1150" b="0" i="0">
+              <a:rPr sz="1200" b="0" i="0">
                 <a:solidFill>
                   <a:srgbClr val="8A97AB"/>
                 </a:solidFill>
                 <a:latin typeface="Microsoft YaHei"/>
                 <a:ea typeface="Microsoft YaHei"/>
               </a:rPr>
-              <a:t>     维护原则未变：前撬拉出检修，不留中间通道，运输高度仍为 2.5 m。</a:t>
-            </a:r>
-          </a:p>
-        </p:txBody>
-      </p:sp>
-      <p:sp>
-        <p:nvSpPr>
-          <p:cNvPr id="9" name="TextBox 8"/>
-          <p:cNvSpPr txBox="1"/>
-          <p:nvPr/>
-        </p:nvSpPr>
-        <p:spPr>
-          <a:xfrm>
-            <a:off x="566928" y="2560320"/>
-            <a:ext cx="11064240" cy="713232"/>
-          </a:xfrm>
-          <a:prstGeom prst="rect">
-            <a:avLst/>
-          </a:prstGeom>
-          <a:noFill/>
-        </p:spPr>
-        <p:txBody>
-          <a:bodyPr wrap="square" lIns="0" rIns="0">
-            <a:spAutoFit/>
-          </a:bodyPr>
-          <a:lstStyle/>
-          <a:p>
-            <a:r>
-              <a:rPr sz="1600" b="1" i="0">
-                <a:solidFill>
-                  <a:srgbClr val="2563EB"/>
-                </a:solidFill>
-                <a:latin typeface="Segoe UI"/>
-                <a:ea typeface="Microsoft YaHei"/>
-              </a:rPr>
-              <a:t>●  </a:t>
-            </a:r>
-            <a:r>
-              <a:rPr sz="1600" b="1" i="0">
-                <a:solidFill>
-                  <a:srgbClr val="1E2B3A"/>
-                </a:solidFill>
-                <a:latin typeface="Segoe UI"/>
-                <a:ea typeface="Microsoft YaHei"/>
-              </a:rPr>
-              <a:t>Tracker: 62 closed, 44 pending, 29 open.  Nothing moved to closed this fortnight.</a:t>
-            </a:r>
-          </a:p>
-          <a:p>
-            <a:pPr>
-              <a:spcBef>
-                <a:spcPts val="100"/>
-              </a:spcBef>
-            </a:pPr>
-            <a:r>
-              <a:rPr sz="1150" b="0" i="0">
-                <a:solidFill>
-                  <a:srgbClr val="8A97AB"/>
-                </a:solidFill>
-                <a:latin typeface="Microsoft YaHei"/>
-                <a:ea typeface="Microsoft YaHei"/>
-              </a:rPr>
-              <a:t>     跟踪表：已关闭 62，待定 44，未关闭 29。本双周没有新的关闭项。</a:t>
-            </a:r>
-          </a:p>
-          <a:p>
-            <a:pPr>
-              <a:spcBef>
-                <a:spcPts val="200"/>
-              </a:spcBef>
-            </a:pPr>
-            <a:r>
-              <a:rPr sz="1200" b="0" i="0">
-                <a:solidFill>
-                  <a:srgbClr val="B7C0CF"/>
-                </a:solidFill>
-                <a:latin typeface="Segoe UI"/>
-                <a:ea typeface="Microsoft YaHei"/>
-              </a:rPr>
-              <a:t>        –  </a:t>
-            </a:r>
-            <a:r>
-              <a:rPr sz="1300" b="0" i="0">
-                <a:solidFill>
-                  <a:srgbClr val="3C4A5A"/>
-                </a:solidFill>
-                <a:latin typeface="Segoe UI"/>
-                <a:ea typeface="Microsoft YaHei"/>
-              </a:rPr>
-              <a:t>The movement is on the model and on three rules Keith set on 22 Sep — not on line-by-line closure.</a:t>
-            </a:r>
-          </a:p>
-          <a:p>
-            <a:r>
-              <a:rPr sz="1000" b="0" i="0">
-                <a:solidFill>
-                  <a:srgbClr val="8A97AB"/>
-                </a:solidFill>
-                <a:latin typeface="Microsoft YaHei"/>
-                <a:ea typeface="Microsoft YaHei"/>
-              </a:rPr>
-              <a:t>             本期推进在模型和 22 日 Keith 定下的三条规则上，不在逐条关项上。</a:t>
-            </a:r>
-          </a:p>
-        </p:txBody>
-      </p:sp>
-      <p:sp>
-        <p:nvSpPr>
-          <p:cNvPr id="10" name="TextBox 9"/>
-          <p:cNvSpPr txBox="1"/>
-          <p:nvPr/>
-        </p:nvSpPr>
-        <p:spPr>
-          <a:xfrm>
-            <a:off x="566928" y="3364992"/>
-            <a:ext cx="11064240" cy="438912"/>
-          </a:xfrm>
-          <a:prstGeom prst="rect">
-            <a:avLst/>
-          </a:prstGeom>
-          <a:noFill/>
-        </p:spPr>
-        <p:txBody>
-          <a:bodyPr wrap="square" lIns="0" rIns="0">
-            <a:spAutoFit/>
-          </a:bodyPr>
-          <a:lstStyle/>
-          <a:p>
-            <a:r>
-              <a:rPr sz="1600" b="1" i="0">
-                <a:solidFill>
-                  <a:srgbClr val="2563EB"/>
-                </a:solidFill>
-                <a:latin typeface="Segoe UI"/>
-                <a:ea typeface="Microsoft YaHei"/>
-              </a:rPr>
-              <a:t>●  </a:t>
-            </a:r>
-            <a:r>
-              <a:rPr sz="1600" b="1" i="0">
-                <a:solidFill>
-                  <a:srgbClr val="1E2B3A"/>
-                </a:solidFill>
-                <a:latin typeface="Segoe UI"/>
-                <a:ea typeface="Microsoft YaHei"/>
-              </a:rPr>
-              <a:t>Critical path has narrowed: nozzle direction and the HTF runs, then Keith can release the 18 Aug equipment drawings.</a:t>
-            </a:r>
-          </a:p>
-          <a:p>
-            <a:pPr>
-              <a:spcBef>
-                <a:spcPts val="100"/>
-              </a:spcBef>
-            </a:pPr>
-            <a:r>
-              <a:rPr sz="1150" b="0" i="0">
-                <a:solidFill>
-                  <a:srgbClr val="8A97AB"/>
-                </a:solidFill>
-                <a:latin typeface="Microsoft YaHei"/>
-                <a:ea typeface="Microsoft YaHei"/>
-              </a:rPr>
-              <a:t>     关键路径收窄为：先定管嘴朝向和 HTF 走向，Keith 才能放行 8 月 18 日的主设备图。</a:t>
-            </a:r>
-          </a:p>
-        </p:txBody>
-      </p:sp>
-      <p:sp>
-        <p:nvSpPr>
-          <p:cNvPr id="11" name="TextBox 10"/>
+              <a:t>关键路径收窄为：先定管嘴朝向和 HTF 走向，Keith 才能放行 8 月 18 日的主设备图。</a:t>
+            </a:r>
+          </a:p>
+        </p:txBody>
+      </p:sp>
+      <p:sp>
+        <p:nvSpPr>
+          <p:cNvPr id="19" name="TextBox 18"/>
           <p:cNvSpPr txBox="1"/>
           <p:nvPr/>
         </p:nvSpPr>
@@ -3635,7 +3953,7 @@
       </p:sp>
       <p:sp>
         <p:nvSpPr>
-          <p:cNvPr id="12" name="TextBox 11"/>
+          <p:cNvPr id="20" name="TextBox 19"/>
           <p:cNvSpPr txBox="1"/>
           <p:nvPr/>
         </p:nvSpPr>
@@ -3664,7 +3982,7 @@
                 <a:latin typeface="Segoe UI"/>
                 <a:ea typeface="Microsoft YaHei"/>
               </a:rPr>
-              <a:t>Bi-weekly Progress 2026-09-09 ~ 09-23    ·    01 / 04</a:t>
+              <a:t>Bi-weekly Progress 2026-09-09 ~ 09-23    ·    01 / 05</a:t>
             </a:r>
           </a:p>
         </p:txBody>
@@ -3909,14 +4227,104 @@
       </p:sp>
       <p:sp>
         <p:nvSpPr>
-          <p:cNvPr id="7" name="TextBox 6"/>
+          <p:cNvPr id="7" name="Rounded Rectangle 6"/>
+          <p:cNvSpPr/>
+          <p:nvPr/>
+        </p:nvSpPr>
+        <p:spPr>
+          <a:xfrm>
+            <a:off x="502920" y="1481328"/>
+            <a:ext cx="11183112" cy="1425194"/>
+          </a:xfrm>
+          <a:prstGeom prst="roundRect">
+            <a:avLst/>
+          </a:prstGeom>
+          <a:solidFill>
+            <a:srgbClr val="F4F7FB"/>
+          </a:solidFill>
+          <a:ln w="12700">
+            <a:solidFill>
+              <a:srgbClr val="E3E8F0"/>
+            </a:solidFill>
+          </a:ln>
+          <a:effectLst/>
+        </p:spPr>
+        <p:style>
+          <a:lnRef idx="1">
+            <a:schemeClr val="accent1"/>
+          </a:lnRef>
+          <a:fillRef idx="3">
+            <a:schemeClr val="accent1"/>
+          </a:fillRef>
+          <a:effectRef idx="2">
+            <a:schemeClr val="accent1"/>
+          </a:effectRef>
+          <a:fontRef idx="minor">
+            <a:schemeClr val="lt1"/>
+          </a:fontRef>
+        </p:style>
+        <p:txBody>
+          <a:bodyPr rtlCol="0" anchor="ctr"/>
+          <a:lstStyle/>
+          <a:p>
+            <a:pPr algn="ctr"/>
+          </a:p>
+        </p:txBody>
+      </p:sp>
+      <p:sp>
+        <p:nvSpPr>
+          <p:cNvPr id="8" name="Rectangle 7"/>
+          <p:cNvSpPr/>
+          <p:nvPr/>
+        </p:nvSpPr>
+        <p:spPr>
+          <a:xfrm>
+            <a:off x="502920" y="1481328"/>
+            <a:ext cx="64008" cy="1425194"/>
+          </a:xfrm>
+          <a:prstGeom prst="rect">
+            <a:avLst/>
+          </a:prstGeom>
+          <a:solidFill>
+            <a:srgbClr val="16A34A"/>
+          </a:solidFill>
+          <a:ln>
+            <a:noFill/>
+          </a:ln>
+          <a:effectLst/>
+        </p:spPr>
+        <p:style>
+          <a:lnRef idx="1">
+            <a:schemeClr val="accent1"/>
+          </a:lnRef>
+          <a:fillRef idx="3">
+            <a:schemeClr val="accent1"/>
+          </a:fillRef>
+          <a:effectRef idx="2">
+            <a:schemeClr val="accent1"/>
+          </a:effectRef>
+          <a:fontRef idx="minor">
+            <a:schemeClr val="lt1"/>
+          </a:fontRef>
+        </p:style>
+        <p:txBody>
+          <a:bodyPr rtlCol="0" anchor="ctr"/>
+          <a:lstStyle/>
+          <a:p>
+            <a:pPr algn="ctr"/>
+          </a:p>
+        </p:txBody>
+      </p:sp>
+      <p:sp>
+        <p:nvSpPr>
+          <p:cNvPr id="9" name="TextBox 8"/>
           <p:cNvSpPr txBox="1"/>
           <p:nvPr/>
         </p:nvSpPr>
         <p:spPr>
           <a:xfrm>
-            <a:off x="566928" y="1481328"/>
-            <a:ext cx="11064240" cy="713232"/>
+            <a:off x="749808" y="1536192"/>
+            <a:ext cx="10744200" cy="1333754"/>
           </a:xfrm>
           <a:prstGeom prst="rect">
             <a:avLst/>
@@ -3924,30 +4332,62 @@
           <a:noFill/>
         </p:spPr>
         <p:txBody>
-          <a:bodyPr wrap="square" lIns="0" rIns="0">
-            <a:spAutoFit/>
-          </a:bodyPr>
-          <a:lstStyle/>
-          <a:p>
-            <a:r>
-              <a:rPr sz="1600" b="1" i="0">
-                <a:solidFill>
-                  <a:srgbClr val="16A34A"/>
+          <a:bodyPr wrap="square" lIns="0" rIns="0" tIns="0" bIns="0"/>
+          <a:lstStyle/>
+          <a:p>
+            <a:r>
+              <a:rPr sz="1500" b="1" i="0">
+                <a:solidFill>
+                  <a:srgbClr val="1E2B3A"/>
                 </a:solidFill>
                 <a:latin typeface="Segoe UI"/>
                 <a:ea typeface="Microsoft YaHei"/>
               </a:rPr>
-              <a:t>●  </a:t>
-            </a:r>
-            <a:r>
-              <a:rPr sz="1600" b="1" i="0">
-                <a:solidFill>
-                  <a:srgbClr val="1E2B3A"/>
+              <a:t>TCU — the wall penetration is fixed.  Ten pipes may stack after the wall.  The five TCU units follow our nozzles.</a:t>
+            </a:r>
+          </a:p>
+          <a:p>
+            <a:pPr>
+              <a:spcBef>
+                <a:spcPts val="300"/>
+              </a:spcBef>
+            </a:pPr>
+            <a:r>
+              <a:rPr sz="1200" b="0" i="0">
+                <a:solidFill>
+                  <a:srgbClr val="8A97AB"/>
+                </a:solidFill>
+                <a:latin typeface="Microsoft YaHei"/>
+                <a:ea typeface="Microsoft YaHei"/>
+              </a:rPr>
+              <a:t>TCU：穿墙位置已定。10 根管过墙后可以叠成两层。5 台 TCU 跟着我方管口走。</a:t>
+            </a:r>
+          </a:p>
+          <a:p>
+            <a:pPr>
+              <a:spcBef>
+                <a:spcPts val="600"/>
+              </a:spcBef>
+            </a:pPr>
+            <a:r>
+              <a:rPr sz="1300" b="0" i="0">
+                <a:solidFill>
+                  <a:srgbClr val="94A3B8"/>
                 </a:solidFill>
                 <a:latin typeface="Segoe UI"/>
                 <a:ea typeface="Microsoft YaHei"/>
               </a:rPr>
-              <a:t>TCU — the wall penetration is fixed.  Ten pipes may stack after the wall.  The five TCU units follow our nozzles.</a:t>
+              <a:t>–  </a:t>
+            </a:r>
+            <a:r>
+              <a:rPr sz="1300" b="0" i="0">
+                <a:solidFill>
+                  <a:srgbClr val="3C4A5A"/>
+                </a:solidFill>
+                <a:latin typeface="Segoe UI"/>
+                <a:ea typeface="Microsoft YaHei"/>
+              </a:rPr>
+              <a:t>One vent on the SW side of the wall, not ten vents on the skid.  Wall plate is flanged both sides — no site weld in the gap.</a:t>
             </a:r>
           </a:p>
           <a:p>
@@ -3957,31 +4397,171 @@
               </a:spcBef>
             </a:pPr>
             <a:r>
-              <a:rPr sz="1150" b="0" i="0">
+              <a:rPr sz="1200" b="0" i="0">
                 <a:solidFill>
                   <a:srgbClr val="8A97AB"/>
                 </a:solidFill>
                 <a:latin typeface="Microsoft YaHei"/>
                 <a:ea typeface="Microsoft YaHei"/>
               </a:rPr>
-              <a:t>     TCU：穿墙位置已定。10 根管过墙后可以叠成两层。5 台 TCU 跟着我方管口走。</a:t>
+              <a:t>排气只留一个点，放在墙的 SW 侧，不在撬上放 10 个排气阀。穿墙板两侧法兰对接，窄处不现场焊接。</a:t>
+            </a:r>
+          </a:p>
+        </p:txBody>
+      </p:sp>
+      <p:sp>
+        <p:nvSpPr>
+          <p:cNvPr id="10" name="Rounded Rectangle 9"/>
+          <p:cNvSpPr/>
+          <p:nvPr/>
+        </p:nvSpPr>
+        <p:spPr>
+          <a:xfrm>
+            <a:off x="502920" y="2979674"/>
+            <a:ext cx="11183112" cy="1883664"/>
+          </a:xfrm>
+          <a:prstGeom prst="roundRect">
+            <a:avLst/>
+          </a:prstGeom>
+          <a:solidFill>
+            <a:srgbClr val="F4F7FB"/>
+          </a:solidFill>
+          <a:ln w="12700">
+            <a:solidFill>
+              <a:srgbClr val="E3E8F0"/>
+            </a:solidFill>
+          </a:ln>
+          <a:effectLst/>
+        </p:spPr>
+        <p:style>
+          <a:lnRef idx="1">
+            <a:schemeClr val="accent1"/>
+          </a:lnRef>
+          <a:fillRef idx="3">
+            <a:schemeClr val="accent1"/>
+          </a:fillRef>
+          <a:effectRef idx="2">
+            <a:schemeClr val="accent1"/>
+          </a:effectRef>
+          <a:fontRef idx="minor">
+            <a:schemeClr val="lt1"/>
+          </a:fontRef>
+        </p:style>
+        <p:txBody>
+          <a:bodyPr rtlCol="0" anchor="ctr"/>
+          <a:lstStyle/>
+          <a:p>
+            <a:pPr algn="ctr"/>
+          </a:p>
+        </p:txBody>
+      </p:sp>
+      <p:sp>
+        <p:nvSpPr>
+          <p:cNvPr id="11" name="Rectangle 10"/>
+          <p:cNvSpPr/>
+          <p:nvPr/>
+        </p:nvSpPr>
+        <p:spPr>
+          <a:xfrm>
+            <a:off x="502920" y="2979674"/>
+            <a:ext cx="64008" cy="1883664"/>
+          </a:xfrm>
+          <a:prstGeom prst="rect">
+            <a:avLst/>
+          </a:prstGeom>
+          <a:solidFill>
+            <a:srgbClr val="16A34A"/>
+          </a:solidFill>
+          <a:ln>
+            <a:noFill/>
+          </a:ln>
+          <a:effectLst/>
+        </p:spPr>
+        <p:style>
+          <a:lnRef idx="1">
+            <a:schemeClr val="accent1"/>
+          </a:lnRef>
+          <a:fillRef idx="3">
+            <a:schemeClr val="accent1"/>
+          </a:fillRef>
+          <a:effectRef idx="2">
+            <a:schemeClr val="accent1"/>
+          </a:effectRef>
+          <a:fontRef idx="minor">
+            <a:schemeClr val="lt1"/>
+          </a:fontRef>
+        </p:style>
+        <p:txBody>
+          <a:bodyPr rtlCol="0" anchor="ctr"/>
+          <a:lstStyle/>
+          <a:p>
+            <a:pPr algn="ctr"/>
+          </a:p>
+        </p:txBody>
+      </p:sp>
+      <p:sp>
+        <p:nvSpPr>
+          <p:cNvPr id="12" name="TextBox 11"/>
+          <p:cNvSpPr txBox="1"/>
+          <p:nvPr/>
+        </p:nvSpPr>
+        <p:spPr>
+          <a:xfrm>
+            <a:off x="749808" y="3034538"/>
+            <a:ext cx="10744200" cy="1792224"/>
+          </a:xfrm>
+          <a:prstGeom prst="rect">
+            <a:avLst/>
+          </a:prstGeom>
+          <a:noFill/>
+        </p:spPr>
+        <p:txBody>
+          <a:bodyPr wrap="square" lIns="0" rIns="0" tIns="0" bIns="0"/>
+          <a:lstStyle/>
+          <a:p>
+            <a:r>
+              <a:rPr sz="1500" b="1" i="0">
+                <a:solidFill>
+                  <a:srgbClr val="1E2B3A"/>
+                </a:solidFill>
+                <a:latin typeface="Segoe UI"/>
+                <a:ea typeface="Microsoft YaHei"/>
+              </a:rPr>
+              <a:t>Layout — two options will be drawn and compared.  Not a freeze yet.</a:t>
             </a:r>
           </a:p>
           <a:p>
             <a:pPr>
               <a:spcBef>
-                <a:spcPts val="200"/>
+                <a:spcPts val="300"/>
               </a:spcBef>
             </a:pPr>
             <a:r>
               <a:rPr sz="1200" b="0" i="0">
                 <a:solidFill>
-                  <a:srgbClr val="B7C0CF"/>
+                  <a:srgbClr val="8A97AB"/>
+                </a:solidFill>
+                <a:latin typeface="Microsoft YaHei"/>
+                <a:ea typeface="Microsoft YaHei"/>
+              </a:rPr>
+              <a:t>布置先出两版对比，这次会上没有冻结。</a:t>
+            </a:r>
+          </a:p>
+          <a:p>
+            <a:pPr>
+              <a:spcBef>
+                <a:spcPts val="600"/>
+              </a:spcBef>
+            </a:pPr>
+            <a:r>
+              <a:rPr sz="1300" b="0" i="0">
+                <a:solidFill>
+                  <a:srgbClr val="94A3B8"/>
                 </a:solidFill>
                 <a:latin typeface="Segoe UI"/>
                 <a:ea typeface="Microsoft YaHei"/>
               </a:rPr>
-              <a:t>        –  </a:t>
+              <a:t>–  </a:t>
             </a:r>
             <a:r>
               <a:rPr sz="1300" b="0" i="0">
@@ -3991,64 +4571,7 @@
                 <a:latin typeface="Segoe UI"/>
                 <a:ea typeface="Microsoft YaHei"/>
               </a:rPr>
-              <a:t>One vent on the SW side of the wall, not ten vents on the skid.  Wall plate is flanged both sides — no site weld in the gap.</a:t>
-            </a:r>
-          </a:p>
-          <a:p>
-            <a:r>
-              <a:rPr sz="1000" b="0" i="0">
-                <a:solidFill>
-                  <a:srgbClr val="8A97AB"/>
-                </a:solidFill>
-                <a:latin typeface="Microsoft YaHei"/>
-                <a:ea typeface="Microsoft YaHei"/>
-              </a:rPr>
-              <a:t>             排气只留一个点，放在墙的 SW 侧，不在撬上放 10 个排气阀。穿墙板两侧法兰对接，窄处不现场焊接。</a:t>
-            </a:r>
-          </a:p>
-        </p:txBody>
-      </p:sp>
-      <p:sp>
-        <p:nvSpPr>
-          <p:cNvPr id="8" name="TextBox 7"/>
-          <p:cNvSpPr txBox="1"/>
-          <p:nvPr/>
-        </p:nvSpPr>
-        <p:spPr>
-          <a:xfrm>
-            <a:off x="566928" y="2249424"/>
-            <a:ext cx="11064240" cy="987552"/>
-          </a:xfrm>
-          <a:prstGeom prst="rect">
-            <a:avLst/>
-          </a:prstGeom>
-          <a:noFill/>
-        </p:spPr>
-        <p:txBody>
-          <a:bodyPr wrap="square" lIns="0" rIns="0">
-            <a:spAutoFit/>
-          </a:bodyPr>
-          <a:lstStyle/>
-          <a:p>
-            <a:r>
-              <a:rPr sz="1600" b="1" i="0">
-                <a:solidFill>
-                  <a:srgbClr val="16A34A"/>
-                </a:solidFill>
-                <a:latin typeface="Segoe UI"/>
-                <a:ea typeface="Microsoft YaHei"/>
-              </a:rPr>
-              <a:t>●  </a:t>
-            </a:r>
-            <a:r>
-              <a:rPr sz="1600" b="1" i="0">
-                <a:solidFill>
-                  <a:srgbClr val="1E2B3A"/>
-                </a:solidFill>
-                <a:latin typeface="Segoe UI"/>
-                <a:ea typeface="Microsoft YaHei"/>
-              </a:rPr>
-              <a:t>Layout — two options will be drawn and compared.  Not a freeze yet.</a:t>
+              <a:t>Fan’s option: swap SE01 / CU01 with the rear valves, so the valves stay in front when the module is pulled.</a:t>
             </a:r>
           </a:p>
           <a:p>
@@ -4058,31 +4581,31 @@
               </a:spcBef>
             </a:pPr>
             <a:r>
-              <a:rPr sz="1150" b="0" i="0">
+              <a:rPr sz="1200" b="0" i="0">
                 <a:solidFill>
                   <a:srgbClr val="8A97AB"/>
                 </a:solidFill>
                 <a:latin typeface="Microsoft YaHei"/>
                 <a:ea typeface="Microsoft YaHei"/>
               </a:rPr>
-              <a:t>     布置先出两版对比，这次会上没有冻结。</a:t>
+              <a:t>范双双的方案：SE01 / CU01 与后部阀门对调，前撬拉出后阀门仍在前面。</a:t>
             </a:r>
           </a:p>
           <a:p>
             <a:pPr>
               <a:spcBef>
-                <a:spcPts val="200"/>
+                <a:spcPts val="600"/>
               </a:spcBef>
             </a:pPr>
             <a:r>
-              <a:rPr sz="1200" b="0" i="0">
-                <a:solidFill>
-                  <a:srgbClr val="B7C0CF"/>
+              <a:rPr sz="1300" b="0" i="0">
+                <a:solidFill>
+                  <a:srgbClr val="94A3B8"/>
                 </a:solidFill>
                 <a:latin typeface="Segoe UI"/>
                 <a:ea typeface="Microsoft YaHei"/>
               </a:rPr>
-              <a:t>        –  </a:t>
+              <a:t>–  </a:t>
             </a:r>
             <a:r>
               <a:rPr sz="1300" b="0" i="0">
@@ -4092,103 +4615,7 @@
                 <a:latin typeface="Segoe UI"/>
                 <a:ea typeface="Microsoft YaHei"/>
               </a:rPr>
-              <a:t>Fan’s option: swap SE01 / CU01 with the rear valves, so the valves stay in front when the module is pulled.</a:t>
-            </a:r>
-          </a:p>
-          <a:p>
-            <a:r>
-              <a:rPr sz="1000" b="0" i="0">
-                <a:solidFill>
-                  <a:srgbClr val="8A97AB"/>
-                </a:solidFill>
-                <a:latin typeface="Microsoft YaHei"/>
-                <a:ea typeface="Microsoft YaHei"/>
-              </a:rPr>
-              <a:t>             范双双的方案：SE01 / CU01 与后部阀门对调，前撬拉出后阀门仍在前面。</a:t>
-            </a:r>
-          </a:p>
-          <a:p>
-            <a:pPr>
-              <a:spcBef>
-                <a:spcPts val="200"/>
-              </a:spcBef>
-            </a:pPr>
-            <a:r>
-              <a:rPr sz="1200" b="0" i="0">
-                <a:solidFill>
-                  <a:srgbClr val="B7C0CF"/>
-                </a:solidFill>
-                <a:latin typeface="Segoe UI"/>
-                <a:ea typeface="Microsoft YaHei"/>
-              </a:rPr>
-              <a:t>        –  </a:t>
-            </a:r>
-            <a:r>
-              <a:rPr sz="1300" b="0" i="0">
-                <a:solidFill>
-                  <a:srgbClr val="3C4A5A"/>
-                </a:solidFill>
-                <a:latin typeface="Segoe UI"/>
-                <a:ea typeface="Microsoft YaHei"/>
-              </a:rPr>
               <a:t>Keith’s option: condenser slightly forward; separator turned to the wall so the level gauge withdraws from the end.  The hole in the middle takes fully welded HTF.</a:t>
-            </a:r>
-          </a:p>
-          <a:p>
-            <a:r>
-              <a:rPr sz="1000" b="0" i="0">
-                <a:solidFill>
-                  <a:srgbClr val="8A97AB"/>
-                </a:solidFill>
-                <a:latin typeface="Microsoft YaHei"/>
-                <a:ea typeface="Microsoft YaHei"/>
-              </a:rPr>
-              <a:t>             Keith 的方案：冷凝器略向前；分离器靠墙转约 90°，液位计从端部抽出。中间空档走全焊接 HTF。</a:t>
-            </a:r>
-          </a:p>
-        </p:txBody>
-      </p:sp>
-      <p:sp>
-        <p:nvSpPr>
-          <p:cNvPr id="9" name="TextBox 8"/>
-          <p:cNvSpPr txBox="1"/>
-          <p:nvPr/>
-        </p:nvSpPr>
-        <p:spPr>
-          <a:xfrm>
-            <a:off x="566928" y="3291840"/>
-            <a:ext cx="11064240" cy="438912"/>
-          </a:xfrm>
-          <a:prstGeom prst="rect">
-            <a:avLst/>
-          </a:prstGeom>
-          <a:noFill/>
-        </p:spPr>
-        <p:txBody>
-          <a:bodyPr wrap="square" lIns="0" rIns="0">
-            <a:spAutoFit/>
-          </a:bodyPr>
-          <a:lstStyle/>
-          <a:p>
-            <a:r>
-              <a:rPr sz="1600" b="1" i="0">
-                <a:solidFill>
-                  <a:srgbClr val="16A34A"/>
-                </a:solidFill>
-                <a:latin typeface="Segoe UI"/>
-                <a:ea typeface="Microsoft YaHei"/>
-              </a:rPr>
-              <a:t>●  </a:t>
-            </a:r>
-            <a:r>
-              <a:rPr sz="1600" b="1" i="0">
-                <a:solidFill>
-                  <a:srgbClr val="1E2B3A"/>
-                </a:solidFill>
-                <a:latin typeface="Segoe UI"/>
-                <a:ea typeface="Microsoft YaHei"/>
-              </a:rPr>
-              <a:t>Reactor 3 HTF nozzle turns toward the wall riser.  The pipe no longer runs out to the skid end and doubles back.</a:t>
             </a:r>
           </a:p>
           <a:p>
@@ -4198,122 +4625,21 @@
               </a:spcBef>
             </a:pPr>
             <a:r>
-              <a:rPr sz="1150" b="0" i="0">
+              <a:rPr sz="1200" b="0" i="0">
                 <a:solidFill>
                   <a:srgbClr val="8A97AB"/>
                 </a:solidFill>
                 <a:latin typeface="Microsoft YaHei"/>
                 <a:ea typeface="Microsoft YaHei"/>
               </a:rPr>
-              <a:t>     反应器 3 的 HTF 管嘴改朝穿墙立管。管子不再先跑到撬端再折回。</a:t>
-            </a:r>
-          </a:p>
-        </p:txBody>
-      </p:sp>
-      <p:sp>
-        <p:nvSpPr>
-          <p:cNvPr id="10" name="TextBox 9"/>
-          <p:cNvSpPr txBox="1"/>
-          <p:nvPr/>
-        </p:nvSpPr>
-        <p:spPr>
-          <a:xfrm>
-            <a:off x="566928" y="3785616"/>
-            <a:ext cx="11064240" cy="713232"/>
-          </a:xfrm>
-          <a:prstGeom prst="rect">
-            <a:avLst/>
-          </a:prstGeom>
-          <a:noFill/>
-        </p:spPr>
-        <p:txBody>
-          <a:bodyPr wrap="square" lIns="0" rIns="0">
-            <a:spAutoFit/>
-          </a:bodyPr>
-          <a:lstStyle/>
-          <a:p>
-            <a:r>
-              <a:rPr sz="1600" b="1" i="0">
-                <a:solidFill>
-                  <a:srgbClr val="16A34A"/>
-                </a:solidFill>
-                <a:latin typeface="Segoe UI"/>
-                <a:ea typeface="Microsoft YaHei"/>
-              </a:rPr>
-              <a:t>●  </a:t>
-            </a:r>
-            <a:r>
-              <a:rPr sz="1600" b="1" i="0">
-                <a:solidFill>
-                  <a:srgbClr val="1E2B3A"/>
-                </a:solidFill>
-                <a:latin typeface="Segoe UI"/>
-                <a:ea typeface="Microsoft YaHei"/>
-              </a:rPr>
-              <a:t>Drains and CIP — valve at the tee, hose at the front.  PSV-025 and PSV-019 stay separate and move to the skid edge.</a:t>
-            </a:r>
-          </a:p>
-          <a:p>
-            <a:pPr>
-              <a:spcBef>
-                <a:spcPts val="100"/>
-              </a:spcBef>
-            </a:pPr>
-            <a:r>
-              <a:rPr sz="1150" b="0" i="0">
-                <a:solidFill>
-                  <a:srgbClr val="8A97AB"/>
-                </a:solidFill>
-                <a:latin typeface="Microsoft YaHei"/>
-                <a:ea typeface="Microsoft YaHei"/>
-              </a:rPr>
-              <a:t>     排净和 CIP：阀紧贴三通，软管接口在撬前。PSV-025 与 PSV-019 不合并，挪到撬边。</a:t>
-            </a:r>
-          </a:p>
-          <a:p>
-            <a:pPr>
-              <a:spcBef>
-                <a:spcPts val="200"/>
-              </a:spcBef>
-            </a:pPr>
-            <a:r>
-              <a:rPr sz="1200" b="0" i="0">
-                <a:solidFill>
-                  <a:srgbClr val="B7C0CF"/>
-                </a:solidFill>
-                <a:latin typeface="Segoe UI"/>
-                <a:ea typeface="Microsoft YaHei"/>
-              </a:rPr>
-              <a:t>        –  </a:t>
-            </a:r>
-            <a:r>
-              <a:rPr sz="1300" b="0" i="0">
-                <a:solidFill>
-                  <a:srgbClr val="3C4A5A"/>
-                </a:solidFill>
-                <a:latin typeface="Segoe UI"/>
-                <a:ea typeface="Microsoft YaHei"/>
-              </a:rPr>
-              <a:t>Unreachable valves take a compact Habonim actuated ball valve, operated from the end.  A 300–400 mm reach can stay manual.</a:t>
-            </a:r>
-          </a:p>
-          <a:p>
-            <a:r>
-              <a:rPr sz="1000" b="0" i="0">
-                <a:solidFill>
-                  <a:srgbClr val="8A97AB"/>
-                </a:solidFill>
-                <a:latin typeface="Microsoft YaHei"/>
-                <a:ea typeface="Microsoft YaHei"/>
-              </a:rPr>
-              <a:t>             够不到的阀用 Habonim 小型气动球阀，在撬端操作。伸手 300–400 mm 能到的可以保持手动。</a:t>
-            </a:r>
-          </a:p>
-        </p:txBody>
-      </p:sp>
-      <p:sp>
-        <p:nvSpPr>
-          <p:cNvPr id="11" name="TextBox 10"/>
+              <a:t>Keith 的方案：冷凝器略向前；分离器靠墙转约 90°，液位计从端部抽出。中间空档走全焊接 HTF。</a:t>
+            </a:r>
+          </a:p>
+        </p:txBody>
+      </p:sp>
+      <p:sp>
+        <p:nvSpPr>
+          <p:cNvPr id="13" name="TextBox 12"/>
           <p:cNvSpPr txBox="1"/>
           <p:nvPr/>
         </p:nvSpPr>
@@ -4348,7 +4674,7 @@
       </p:sp>
       <p:sp>
         <p:nvSpPr>
-          <p:cNvPr id="12" name="TextBox 11"/>
+          <p:cNvPr id="14" name="TextBox 13"/>
           <p:cNvSpPr txBox="1"/>
           <p:nvPr/>
         </p:nvSpPr>
@@ -4377,7 +4703,7 @@
                 <a:latin typeface="Segoe UI"/>
                 <a:ea typeface="Microsoft YaHei"/>
               </a:rPr>
-              <a:t>Bi-weekly Progress 2026-09-09 ~ 09-23    ·    02 / 04</a:t>
+              <a:t>Bi-weekly Progress 2026-09-09 ~ 09-23    ·    02 / 05</a:t>
             </a:r>
           </a:p>
         </p:txBody>
@@ -4415,7 +4741,7 @@
             <a:avLst/>
           </a:prstGeom>
           <a:solidFill>
-            <a:srgbClr val="DC2626"/>
+            <a:srgbClr val="16A34A"/>
           </a:solidFill>
           <a:ln>
             <a:noFill/>
@@ -4459,7 +4785,7 @@
             <a:avLst/>
           </a:prstGeom>
           <a:solidFill>
-            <a:srgbClr val="DC2626"/>
+            <a:srgbClr val="16A34A"/>
           </a:solidFill>
           <a:ln>
             <a:noFill/>
@@ -4549,12 +4875,12 @@
             <a:r>
               <a:rPr sz="2800" b="1" i="0">
                 <a:solidFill>
-                  <a:srgbClr val="DC2626"/>
+                  <a:srgbClr val="16A34A"/>
                 </a:solidFill>
                 <a:latin typeface="Segoe UI"/>
                 <a:ea typeface="Microsoft YaHei"/>
               </a:rPr>
-              <a:t>What Changes the Plan</a:t>
+              <a:t>Piping Rules from 22 Sep</a:t>
             </a:r>
           </a:p>
           <a:p>
@@ -4571,7 +4897,7 @@
                 <a:latin typeface="Microsoft YaHei"/>
                 <a:ea typeface="Microsoft YaHei"/>
               </a:rPr>
-              <a:t>相对 9 月 9 日计划的变化</a:t>
+              <a:t>9 月 22 日定下的管路规则</a:t>
             </a:r>
           </a:p>
         </p:txBody>
@@ -4622,14 +4948,104 @@
       </p:sp>
       <p:sp>
         <p:nvSpPr>
-          <p:cNvPr id="7" name="TextBox 6"/>
+          <p:cNvPr id="7" name="Rounded Rectangle 6"/>
+          <p:cNvSpPr/>
+          <p:nvPr/>
+        </p:nvSpPr>
+        <p:spPr>
+          <a:xfrm>
+            <a:off x="502920" y="1499616"/>
+            <a:ext cx="11183112" cy="935736"/>
+          </a:xfrm>
+          <a:prstGeom prst="roundRect">
+            <a:avLst/>
+          </a:prstGeom>
+          <a:solidFill>
+            <a:srgbClr val="F4F7FB"/>
+          </a:solidFill>
+          <a:ln w="12700">
+            <a:solidFill>
+              <a:srgbClr val="E3E8F0"/>
+            </a:solidFill>
+          </a:ln>
+          <a:effectLst/>
+        </p:spPr>
+        <p:style>
+          <a:lnRef idx="1">
+            <a:schemeClr val="accent1"/>
+          </a:lnRef>
+          <a:fillRef idx="3">
+            <a:schemeClr val="accent1"/>
+          </a:fillRef>
+          <a:effectRef idx="2">
+            <a:schemeClr val="accent1"/>
+          </a:effectRef>
+          <a:fontRef idx="minor">
+            <a:schemeClr val="lt1"/>
+          </a:fontRef>
+        </p:style>
+        <p:txBody>
+          <a:bodyPr rtlCol="0" anchor="ctr"/>
+          <a:lstStyle/>
+          <a:p>
+            <a:pPr algn="ctr"/>
+          </a:p>
+        </p:txBody>
+      </p:sp>
+      <p:sp>
+        <p:nvSpPr>
+          <p:cNvPr id="8" name="Rectangle 7"/>
+          <p:cNvSpPr/>
+          <p:nvPr/>
+        </p:nvSpPr>
+        <p:spPr>
+          <a:xfrm>
+            <a:off x="502920" y="1499616"/>
+            <a:ext cx="64008" cy="935736"/>
+          </a:xfrm>
+          <a:prstGeom prst="rect">
+            <a:avLst/>
+          </a:prstGeom>
+          <a:solidFill>
+            <a:srgbClr val="16A34A"/>
+          </a:solidFill>
+          <a:ln>
+            <a:noFill/>
+          </a:ln>
+          <a:effectLst/>
+        </p:spPr>
+        <p:style>
+          <a:lnRef idx="1">
+            <a:schemeClr val="accent1"/>
+          </a:lnRef>
+          <a:fillRef idx="3">
+            <a:schemeClr val="accent1"/>
+          </a:fillRef>
+          <a:effectRef idx="2">
+            <a:schemeClr val="accent1"/>
+          </a:effectRef>
+          <a:fontRef idx="minor">
+            <a:schemeClr val="lt1"/>
+          </a:fontRef>
+        </p:style>
+        <p:txBody>
+          <a:bodyPr rtlCol="0" anchor="ctr"/>
+          <a:lstStyle/>
+          <a:p>
+            <a:pPr algn="ctr"/>
+          </a:p>
+        </p:txBody>
+      </p:sp>
+      <p:sp>
+        <p:nvSpPr>
+          <p:cNvPr id="9" name="TextBox 8"/>
           <p:cNvSpPr txBox="1"/>
           <p:nvPr/>
         </p:nvSpPr>
         <p:spPr>
           <a:xfrm>
-            <a:off x="566928" y="1481328"/>
-            <a:ext cx="11064240" cy="713232"/>
+            <a:off x="749808" y="1554480"/>
+            <a:ext cx="10744200" cy="844296"/>
           </a:xfrm>
           <a:prstGeom prst="rect">
             <a:avLst/>
@@ -4637,30 +5053,202 @@
           <a:noFill/>
         </p:spPr>
         <p:txBody>
-          <a:bodyPr wrap="square" lIns="0" rIns="0">
-            <a:spAutoFit/>
-          </a:bodyPr>
-          <a:lstStyle/>
-          <a:p>
-            <a:r>
-              <a:rPr sz="1600" b="1" i="0">
-                <a:solidFill>
-                  <a:srgbClr val="DC2626"/>
+          <a:bodyPr wrap="square" lIns="0" rIns="0" tIns="0" bIns="0"/>
+          <a:lstStyle/>
+          <a:p>
+            <a:r>
+              <a:rPr sz="1500" b="1" i="0">
+                <a:solidFill>
+                  <a:srgbClr val="1E2B3A"/>
                 </a:solidFill>
                 <a:latin typeface="Segoe UI"/>
                 <a:ea typeface="Microsoft YaHei"/>
               </a:rPr>
-              <a:t>●  </a:t>
-            </a:r>
-            <a:r>
-              <a:rPr sz="1600" b="1" i="0">
+              <a:t>Reactor 3 HTF nozzle turns toward the wall riser.  The pipe no longer runs out to the skid end and doubles back.</a:t>
+            </a:r>
+          </a:p>
+          <a:p>
+            <a:pPr>
+              <a:spcBef>
+                <a:spcPts val="300"/>
+              </a:spcBef>
+            </a:pPr>
+            <a:r>
+              <a:rPr sz="1200" b="0" i="0">
+                <a:solidFill>
+                  <a:srgbClr val="8A97AB"/>
+                </a:solidFill>
+                <a:latin typeface="Microsoft YaHei"/>
+                <a:ea typeface="Microsoft YaHei"/>
+              </a:rPr>
+              <a:t>反应器 3 的 HTF 管嘴改朝穿墙立管。管子不再先跑到撬端再折回。</a:t>
+            </a:r>
+          </a:p>
+        </p:txBody>
+      </p:sp>
+      <p:sp>
+        <p:nvSpPr>
+          <p:cNvPr id="10" name="Rounded Rectangle 9"/>
+          <p:cNvSpPr/>
+          <p:nvPr/>
+        </p:nvSpPr>
+        <p:spPr>
+          <a:xfrm>
+            <a:off x="502920" y="2563368"/>
+            <a:ext cx="11183112" cy="1626616"/>
+          </a:xfrm>
+          <a:prstGeom prst="roundRect">
+            <a:avLst/>
+          </a:prstGeom>
+          <a:solidFill>
+            <a:srgbClr val="F4F7FB"/>
+          </a:solidFill>
+          <a:ln w="12700">
+            <a:solidFill>
+              <a:srgbClr val="E3E8F0"/>
+            </a:solidFill>
+          </a:ln>
+          <a:effectLst/>
+        </p:spPr>
+        <p:style>
+          <a:lnRef idx="1">
+            <a:schemeClr val="accent1"/>
+          </a:lnRef>
+          <a:fillRef idx="3">
+            <a:schemeClr val="accent1"/>
+          </a:fillRef>
+          <a:effectRef idx="2">
+            <a:schemeClr val="accent1"/>
+          </a:effectRef>
+          <a:fontRef idx="minor">
+            <a:schemeClr val="lt1"/>
+          </a:fontRef>
+        </p:style>
+        <p:txBody>
+          <a:bodyPr rtlCol="0" anchor="ctr"/>
+          <a:lstStyle/>
+          <a:p>
+            <a:pPr algn="ctr"/>
+          </a:p>
+        </p:txBody>
+      </p:sp>
+      <p:sp>
+        <p:nvSpPr>
+          <p:cNvPr id="11" name="Rectangle 10"/>
+          <p:cNvSpPr/>
+          <p:nvPr/>
+        </p:nvSpPr>
+        <p:spPr>
+          <a:xfrm>
+            <a:off x="502920" y="2563368"/>
+            <a:ext cx="64008" cy="1626616"/>
+          </a:xfrm>
+          <a:prstGeom prst="rect">
+            <a:avLst/>
+          </a:prstGeom>
+          <a:solidFill>
+            <a:srgbClr val="16A34A"/>
+          </a:solidFill>
+          <a:ln>
+            <a:noFill/>
+          </a:ln>
+          <a:effectLst/>
+        </p:spPr>
+        <p:style>
+          <a:lnRef idx="1">
+            <a:schemeClr val="accent1"/>
+          </a:lnRef>
+          <a:fillRef idx="3">
+            <a:schemeClr val="accent1"/>
+          </a:fillRef>
+          <a:effectRef idx="2">
+            <a:schemeClr val="accent1"/>
+          </a:effectRef>
+          <a:fontRef idx="minor">
+            <a:schemeClr val="lt1"/>
+          </a:fontRef>
+        </p:style>
+        <p:txBody>
+          <a:bodyPr rtlCol="0" anchor="ctr"/>
+          <a:lstStyle/>
+          <a:p>
+            <a:pPr algn="ctr"/>
+          </a:p>
+        </p:txBody>
+      </p:sp>
+      <p:sp>
+        <p:nvSpPr>
+          <p:cNvPr id="12" name="TextBox 11"/>
+          <p:cNvSpPr txBox="1"/>
+          <p:nvPr/>
+        </p:nvSpPr>
+        <p:spPr>
+          <a:xfrm>
+            <a:off x="749808" y="2618232"/>
+            <a:ext cx="10744200" cy="1535176"/>
+          </a:xfrm>
+          <a:prstGeom prst="rect">
+            <a:avLst/>
+          </a:prstGeom>
+          <a:noFill/>
+        </p:spPr>
+        <p:txBody>
+          <a:bodyPr wrap="square" lIns="0" rIns="0" tIns="0" bIns="0"/>
+          <a:lstStyle/>
+          <a:p>
+            <a:r>
+              <a:rPr sz="1500" b="1" i="0">
                 <a:solidFill>
                   <a:srgbClr val="1E2B3A"/>
                 </a:solidFill>
                 <a:latin typeface="Segoe UI"/>
                 <a:ea typeface="Microsoft YaHei"/>
               </a:rPr>
-              <a:t>Main-equipment enquiry now waits on nozzle orientation and the HTF runs — not on a full drawing sign-off, and not on the UK visit.</a:t>
+              <a:t>Drains and CIP — valve at the tee, hose at the front.  PSV-025 and PSV-019 stay separate and move to the skid edge.</a:t>
+            </a:r>
+          </a:p>
+          <a:p>
+            <a:pPr>
+              <a:spcBef>
+                <a:spcPts val="300"/>
+              </a:spcBef>
+            </a:pPr>
+            <a:r>
+              <a:rPr sz="1200" b="0" i="0">
+                <a:solidFill>
+                  <a:srgbClr val="8A97AB"/>
+                </a:solidFill>
+                <a:latin typeface="Microsoft YaHei"/>
+                <a:ea typeface="Microsoft YaHei"/>
+              </a:rPr>
+              <a:t>排净和 CIP：阀紧贴三通，软管接口在撬前。PSV-025 与 PSV-019 不合并，挪到撬边。</a:t>
+            </a:r>
+          </a:p>
+          <a:p>
+            <a:pPr>
+              <a:spcBef>
+                <a:spcPts val="600"/>
+              </a:spcBef>
+            </a:pPr>
+            <a:r>
+              <a:rPr sz="1300" b="0" i="0">
+                <a:solidFill>
+                  <a:srgbClr val="94A3B8"/>
+                </a:solidFill>
+                <a:latin typeface="Segoe UI"/>
+                <a:ea typeface="Microsoft YaHei"/>
+              </a:rPr>
+              <a:t>–  </a:t>
+            </a:r>
+            <a:r>
+              <a:rPr sz="1300" b="0" i="0">
+                <a:solidFill>
+                  <a:srgbClr val="3C4A5A"/>
+                </a:solidFill>
+                <a:latin typeface="Segoe UI"/>
+                <a:ea typeface="Microsoft YaHei"/>
+              </a:rPr>
+              <a:t>Unreachable valves take a compact Habonim actuated ball valve, operated from the end.  A 300–400 mm reach can stay manual.</a:t>
             </a:r>
           </a:p>
           <a:p>
@@ -4670,324 +5258,161 @@
               </a:spcBef>
             </a:pPr>
             <a:r>
-              <a:rPr sz="1150" b="0" i="0">
+              <a:rPr sz="1200" b="0" i="0">
                 <a:solidFill>
                   <a:srgbClr val="8A97AB"/>
                 </a:solidFill>
                 <a:latin typeface="Microsoft YaHei"/>
                 <a:ea typeface="Microsoft YaHei"/>
               </a:rPr>
-              <a:t>     主设备询价改为等管嘴朝向和 HTF 走向。不等整套图纸签完，也不等赴英。</a:t>
+              <a:t>够不到的阀用 Habonim 小型气动球阀，在撬端操作。伸手 300–400 mm 能到的可以保持手动。</a:t>
+            </a:r>
+          </a:p>
+        </p:txBody>
+      </p:sp>
+      <p:sp>
+        <p:nvSpPr>
+          <p:cNvPr id="13" name="Rounded Rectangle 12"/>
+          <p:cNvSpPr/>
+          <p:nvPr/>
+        </p:nvSpPr>
+        <p:spPr>
+          <a:xfrm>
+            <a:off x="502920" y="4318000"/>
+            <a:ext cx="11183112" cy="935736"/>
+          </a:xfrm>
+          <a:prstGeom prst="roundRect">
+            <a:avLst/>
+          </a:prstGeom>
+          <a:solidFill>
+            <a:srgbClr val="F4F7FB"/>
+          </a:solidFill>
+          <a:ln w="12700">
+            <a:solidFill>
+              <a:srgbClr val="E3E8F0"/>
+            </a:solidFill>
+          </a:ln>
+          <a:effectLst/>
+        </p:spPr>
+        <p:style>
+          <a:lnRef idx="1">
+            <a:schemeClr val="accent1"/>
+          </a:lnRef>
+          <a:fillRef idx="3">
+            <a:schemeClr val="accent1"/>
+          </a:fillRef>
+          <a:effectRef idx="2">
+            <a:schemeClr val="accent1"/>
+          </a:effectRef>
+          <a:fontRef idx="minor">
+            <a:schemeClr val="lt1"/>
+          </a:fontRef>
+        </p:style>
+        <p:txBody>
+          <a:bodyPr rtlCol="0" anchor="ctr"/>
+          <a:lstStyle/>
+          <a:p>
+            <a:pPr algn="ctr"/>
+          </a:p>
+        </p:txBody>
+      </p:sp>
+      <p:sp>
+        <p:nvSpPr>
+          <p:cNvPr id="14" name="Rectangle 13"/>
+          <p:cNvSpPr/>
+          <p:nvPr/>
+        </p:nvSpPr>
+        <p:spPr>
+          <a:xfrm>
+            <a:off x="502920" y="4318000"/>
+            <a:ext cx="64008" cy="935736"/>
+          </a:xfrm>
+          <a:prstGeom prst="rect">
+            <a:avLst/>
+          </a:prstGeom>
+          <a:solidFill>
+            <a:srgbClr val="16A34A"/>
+          </a:solidFill>
+          <a:ln>
+            <a:noFill/>
+          </a:ln>
+          <a:effectLst/>
+        </p:spPr>
+        <p:style>
+          <a:lnRef idx="1">
+            <a:schemeClr val="accent1"/>
+          </a:lnRef>
+          <a:fillRef idx="3">
+            <a:schemeClr val="accent1"/>
+          </a:fillRef>
+          <a:effectRef idx="2">
+            <a:schemeClr val="accent1"/>
+          </a:effectRef>
+          <a:fontRef idx="minor">
+            <a:schemeClr val="lt1"/>
+          </a:fontRef>
+        </p:style>
+        <p:txBody>
+          <a:bodyPr rtlCol="0" anchor="ctr"/>
+          <a:lstStyle/>
+          <a:p>
+            <a:pPr algn="ctr"/>
+          </a:p>
+        </p:txBody>
+      </p:sp>
+      <p:sp>
+        <p:nvSpPr>
+          <p:cNvPr id="15" name="TextBox 14"/>
+          <p:cNvSpPr txBox="1"/>
+          <p:nvPr/>
+        </p:nvSpPr>
+        <p:spPr>
+          <a:xfrm>
+            <a:off x="749808" y="4372864"/>
+            <a:ext cx="10744200" cy="844296"/>
+          </a:xfrm>
+          <a:prstGeom prst="rect">
+            <a:avLst/>
+          </a:prstGeom>
+          <a:noFill/>
+        </p:spPr>
+        <p:txBody>
+          <a:bodyPr wrap="square" lIns="0" rIns="0" tIns="0" bIns="0"/>
+          <a:lstStyle/>
+          <a:p>
+            <a:r>
+              <a:rPr sz="1500" b="1" i="0">
+                <a:solidFill>
+                  <a:srgbClr val="1E2B3A"/>
+                </a:solidFill>
+                <a:latin typeface="Segoe UI"/>
+                <a:ea typeface="Microsoft YaHei"/>
+              </a:rPr>
+              <a:t>Width cannot drop 100–200 mm — the limit is the pump and BT01.  Cleaning-mode high-level bypass is written into the manual, and is not yet agreed with Keith.</a:t>
             </a:r>
           </a:p>
           <a:p>
             <a:pPr>
               <a:spcBef>
-                <a:spcPts val="200"/>
+                <a:spcPts val="300"/>
               </a:spcBef>
             </a:pPr>
             <a:r>
               <a:rPr sz="1200" b="0" i="0">
                 <a:solidFill>
-                  <a:srgbClr val="B7C0CF"/>
-                </a:solidFill>
-                <a:latin typeface="Segoe UI"/>
-                <a:ea typeface="Microsoft YaHei"/>
-              </a:rPr>
-              <a:t>        –  </a:t>
-            </a:r>
-            <a:r>
-              <a:rPr sz="1300" b="0" i="0">
-                <a:solidFill>
-                  <a:srgbClr val="3C4A5A"/>
-                </a:solidFill>
-                <a:latin typeface="Segoe UI"/>
-                <a:ea typeface="Microsoft YaHei"/>
-              </a:rPr>
-              <a:t>9 Sep allowed the enquiry once the reactor specification was confirmed.  On 22 Sep Keith would not comment on the 18 Aug drawings until those nozzles are shown to fit.</a:t>
-            </a:r>
-          </a:p>
-          <a:p>
-            <a:r>
-              <a:rPr sz="1000" b="0" i="0">
-                <a:solidFill>
                   <a:srgbClr val="8A97AB"/>
                 </a:solidFill>
                 <a:latin typeface="Microsoft YaHei"/>
                 <a:ea typeface="Microsoft YaHei"/>
               </a:rPr>
-              <a:t>             9 月 9 日的口径是反应柱规格确认后即可询价。22 日 Keith 明确：管嘴方向和 HTF 没在模型里站住之前，他不审 8 月 18 日的图。</a:t>
-            </a:r>
-          </a:p>
-        </p:txBody>
-      </p:sp>
-      <p:sp>
-        <p:nvSpPr>
-          <p:cNvPr id="8" name="TextBox 7"/>
-          <p:cNvSpPr txBox="1"/>
-          <p:nvPr/>
-        </p:nvSpPr>
-        <p:spPr>
-          <a:xfrm>
-            <a:off x="566928" y="2267712"/>
-            <a:ext cx="11064240" cy="713232"/>
-          </a:xfrm>
-          <a:prstGeom prst="rect">
-            <a:avLst/>
-          </a:prstGeom>
-          <a:noFill/>
-        </p:spPr>
-        <p:txBody>
-          <a:bodyPr wrap="square" lIns="0" rIns="0">
-            <a:spAutoFit/>
-          </a:bodyPr>
-          <a:lstStyle/>
-          <a:p>
-            <a:r>
-              <a:rPr sz="1600" b="1" i="0">
-                <a:solidFill>
-                  <a:srgbClr val="DC2626"/>
-                </a:solidFill>
-                <a:latin typeface="Segoe UI"/>
-                <a:ea typeface="Microsoft YaHei"/>
-              </a:rPr>
-              <a:t>●  </a:t>
-            </a:r>
-            <a:r>
-              <a:rPr sz="1600" b="1" i="0">
-                <a:solidFill>
-                  <a:srgbClr val="1E2B3A"/>
-                </a:solidFill>
-                <a:latin typeface="Segoe UI"/>
-                <a:ea typeface="Microsoft YaHei"/>
-              </a:rPr>
-              <a:t>Charging stairs — SW supplies them in the UK, in stainless steel, separate from the main-equipment order.</a:t>
-            </a:r>
-          </a:p>
-          <a:p>
-            <a:pPr>
-              <a:spcBef>
-                <a:spcPts val="100"/>
-              </a:spcBef>
-            </a:pPr>
-            <a:r>
-              <a:rPr sz="1150" b="0" i="0">
-                <a:solidFill>
-                  <a:srgbClr val="8A97AB"/>
-                </a:solidFill>
-                <a:latin typeface="Microsoft YaHei"/>
-                <a:ea typeface="Microsoft YaHei"/>
-              </a:rPr>
-              <a:t>     加料梯由 SW 在英国供货，不锈钢，不并进主设备采购。</a:t>
-            </a:r>
-          </a:p>
-          <a:p>
-            <a:pPr>
-              <a:spcBef>
-                <a:spcPts val="200"/>
-              </a:spcBef>
-            </a:pPr>
-            <a:r>
-              <a:rPr sz="1200" b="0" i="0">
-                <a:solidFill>
-                  <a:srgbClr val="B7C0CF"/>
-                </a:solidFill>
-                <a:latin typeface="Segoe UI"/>
-                <a:ea typeface="Microsoft YaHei"/>
-              </a:rPr>
-              <a:t>        –  </a:t>
-            </a:r>
-            <a:r>
-              <a:rPr sz="1300" b="0" i="0">
-                <a:solidFill>
-                  <a:srgbClr val="3C4A5A"/>
-                </a:solidFill>
-                <a:latin typeface="Segoe UI"/>
-                <a:ea typeface="Microsoft YaHei"/>
-              </a:rPr>
-              <a:t>A catalogue aluminium stair is not acceptable.  China will not design or fabricate this item.  Target height is under 1.4 m.</a:t>
-            </a:r>
-          </a:p>
-          <a:p>
-            <a:r>
-              <a:rPr sz="1000" b="0" i="0">
-                <a:solidFill>
-                  <a:srgbClr val="8A97AB"/>
-                </a:solidFill>
-                <a:latin typeface="Microsoft YaHei"/>
-                <a:ea typeface="Microsoft YaHei"/>
-              </a:rPr>
-              <a:t>             不用成品铝梯。中方不设计、不制造。高度目标低于 1.4 m。</a:t>
-            </a:r>
-          </a:p>
-        </p:txBody>
-      </p:sp>
-      <p:sp>
-        <p:nvSpPr>
-          <p:cNvPr id="9" name="TextBox 8"/>
-          <p:cNvSpPr txBox="1"/>
-          <p:nvPr/>
-        </p:nvSpPr>
-        <p:spPr>
-          <a:xfrm>
-            <a:off x="566928" y="3054096"/>
-            <a:ext cx="11064240" cy="713232"/>
-          </a:xfrm>
-          <a:prstGeom prst="rect">
-            <a:avLst/>
-          </a:prstGeom>
-          <a:noFill/>
-        </p:spPr>
-        <p:txBody>
-          <a:bodyPr wrap="square" lIns="0" rIns="0">
-            <a:spAutoFit/>
-          </a:bodyPr>
-          <a:lstStyle/>
-          <a:p>
-            <a:r>
-              <a:rPr sz="1600" b="1" i="0">
-                <a:solidFill>
-                  <a:srgbClr val="DC2626"/>
-                </a:solidFill>
-                <a:latin typeface="Segoe UI"/>
-                <a:ea typeface="Microsoft YaHei"/>
-              </a:rPr>
-              <a:t>●  </a:t>
-            </a:r>
-            <a:r>
-              <a:rPr sz="1600" b="1" i="0">
-                <a:solidFill>
-                  <a:srgbClr val="1E2B3A"/>
-                </a:solidFill>
-                <a:latin typeface="Segoe UI"/>
-                <a:ea typeface="Microsoft YaHei"/>
-              </a:rPr>
-              <a:t>12–22 October is still the proposed visit.  It is not confirmed.  An early-November window is being checked.</a:t>
-            </a:r>
-          </a:p>
-          <a:p>
-            <a:pPr>
-              <a:spcBef>
-                <a:spcPts val="100"/>
-              </a:spcBef>
-            </a:pPr>
-            <a:r>
-              <a:rPr sz="1150" b="0" i="0">
-                <a:solidFill>
-                  <a:srgbClr val="8A97AB"/>
-                </a:solidFill>
-                <a:latin typeface="Microsoft YaHei"/>
-                <a:ea typeface="Microsoft YaHei"/>
-              </a:rPr>
-              <a:t>     10 月 12–22 日仍是建议行程，尚未确认。11 月初的备选窗口正在核实。</a:t>
-            </a:r>
-          </a:p>
-          <a:p>
-            <a:pPr>
-              <a:spcBef>
-                <a:spcPts val="200"/>
-              </a:spcBef>
-            </a:pPr>
-            <a:r>
-              <a:rPr sz="1200" b="0" i="0">
-                <a:solidFill>
-                  <a:srgbClr val="B7C0CF"/>
-                </a:solidFill>
-                <a:latin typeface="Segoe UI"/>
-                <a:ea typeface="Microsoft YaHei"/>
-              </a:rPr>
-              <a:t>        –  </a:t>
-            </a:r>
-            <a:r>
-              <a:rPr sz="1300" b="0" i="0">
-                <a:solidFill>
-                  <a:srgbClr val="3C4A5A"/>
-                </a:solidFill>
-                <a:latin typeface="Segoe UI"/>
-                <a:ea typeface="Microsoft YaHei"/>
-              </a:rPr>
-              <a:t>The model work this week does not wait for that confirmation.</a:t>
-            </a:r>
-          </a:p>
-          <a:p>
-            <a:r>
-              <a:rPr sz="1000" b="0" i="0">
-                <a:solidFill>
-                  <a:srgbClr val="8A97AB"/>
-                </a:solidFill>
-                <a:latin typeface="Microsoft YaHei"/>
-                <a:ea typeface="Microsoft YaHei"/>
-              </a:rPr>
-              <a:t>             本周的模型工作不等这个日期。</a:t>
-            </a:r>
-          </a:p>
-        </p:txBody>
-      </p:sp>
-      <p:sp>
-        <p:nvSpPr>
-          <p:cNvPr id="10" name="TextBox 9"/>
-          <p:cNvSpPr txBox="1"/>
-          <p:nvPr/>
-        </p:nvSpPr>
-        <p:spPr>
-          <a:xfrm>
-            <a:off x="566928" y="3840479"/>
-            <a:ext cx="11064240" cy="438912"/>
-          </a:xfrm>
-          <a:prstGeom prst="rect">
-            <a:avLst/>
-          </a:prstGeom>
-          <a:noFill/>
-        </p:spPr>
-        <p:txBody>
-          <a:bodyPr wrap="square" lIns="0" rIns="0">
-            <a:spAutoFit/>
-          </a:bodyPr>
-          <a:lstStyle/>
-          <a:p>
-            <a:r>
-              <a:rPr sz="1400" b="1" i="0">
-                <a:solidFill>
-                  <a:srgbClr val="8A97AB"/>
-                </a:solidFill>
-                <a:latin typeface="Segoe UI"/>
-                <a:ea typeface="Microsoft YaHei"/>
-              </a:rPr>
-              <a:t>●  </a:t>
-            </a:r>
-            <a:r>
-              <a:rPr sz="1400" b="0" i="0">
-                <a:solidFill>
-                  <a:srgbClr val="5A6675"/>
-                </a:solidFill>
-                <a:latin typeface="Segoe UI"/>
-                <a:ea typeface="Microsoft YaHei"/>
-              </a:rPr>
-              <a:t>Still open, and not a layout choice for this meeting: width cannot drop 100–200 mm (pump and BT01).  Cleaning-mode high-level bypass is in the manual, not yet agreed.</a:t>
-            </a:r>
-          </a:p>
-          <a:p>
-            <a:pPr>
-              <a:spcBef>
-                <a:spcPts val="100"/>
-              </a:spcBef>
-            </a:pPr>
-            <a:r>
-              <a:rPr sz="1050" b="0" i="0">
-                <a:solidFill>
-                  <a:srgbClr val="8A97AB"/>
-                </a:solidFill>
-                <a:latin typeface="Microsoft YaHei"/>
-                <a:ea typeface="Microsoft YaHei"/>
-              </a:rPr>
-              <a:t>     本次不需要领导选型。宽度受泵和 BT01 限制，减 100–200 mm 没有意义。清洗模式旁路高液位联锁已写入手册，Keith 尚未认可。</a:t>
-            </a:r>
-          </a:p>
-        </p:txBody>
-      </p:sp>
-      <p:sp>
-        <p:nvSpPr>
-          <p:cNvPr id="11" name="TextBox 10"/>
+              <a:t>宽度减不了 100–200 mm，限制在泵和 BT01。清洗模式旁路高液位联锁已写入手册，Keith 尚未认可。</a:t>
+            </a:r>
+          </a:p>
+        </p:txBody>
+      </p:sp>
+      <p:sp>
+        <p:nvSpPr>
+          <p:cNvPr id="16" name="TextBox 15"/>
           <p:cNvSpPr txBox="1"/>
           <p:nvPr/>
         </p:nvSpPr>
@@ -5022,7 +5447,7 @@
       </p:sp>
       <p:sp>
         <p:nvSpPr>
-          <p:cNvPr id="12" name="TextBox 11"/>
+          <p:cNvPr id="17" name="TextBox 16"/>
           <p:cNvSpPr txBox="1"/>
           <p:nvPr/>
         </p:nvSpPr>
@@ -5051,7 +5476,7 @@
                 <a:latin typeface="Segoe UI"/>
                 <a:ea typeface="Microsoft YaHei"/>
               </a:rPr>
-              <a:t>Bi-weekly Progress 2026-09-09 ~ 09-23    ·    03 / 04</a:t>
+              <a:t>Bi-weekly Progress 2026-09-09 ~ 09-23    ·    03 / 05</a:t>
             </a:r>
           </a:p>
         </p:txBody>
@@ -5089,7 +5514,7 @@
             <a:avLst/>
           </a:prstGeom>
           <a:solidFill>
-            <a:srgbClr val="0E9AA7"/>
+            <a:srgbClr val="DC2626"/>
           </a:solidFill>
           <a:ln>
             <a:noFill/>
@@ -5130,6 +5555,823 @@
             <a:ext cx="841248" cy="841248"/>
           </a:xfrm>
           <a:prstGeom prst="roundRect">
+            <a:avLst/>
+          </a:prstGeom>
+          <a:solidFill>
+            <a:srgbClr val="DC2626"/>
+          </a:solidFill>
+          <a:ln>
+            <a:noFill/>
+          </a:ln>
+          <a:effectLst/>
+        </p:spPr>
+        <p:style>
+          <a:lnRef idx="1">
+            <a:schemeClr val="accent1"/>
+          </a:lnRef>
+          <a:fillRef idx="3">
+            <a:schemeClr val="accent1"/>
+          </a:fillRef>
+          <a:effectRef idx="2">
+            <a:schemeClr val="accent1"/>
+          </a:effectRef>
+          <a:fontRef idx="minor">
+            <a:schemeClr val="lt1"/>
+          </a:fontRef>
+        </p:style>
+        <p:txBody>
+          <a:bodyPr rtlCol="0" anchor="ctr"/>
+          <a:lstStyle/>
+          <a:p>
+            <a:pPr algn="ctr"/>
+          </a:p>
+        </p:txBody>
+      </p:sp>
+      <p:sp>
+        <p:nvSpPr>
+          <p:cNvPr id="4" name="TextBox 3"/>
+          <p:cNvSpPr txBox="1"/>
+          <p:nvPr/>
+        </p:nvSpPr>
+        <p:spPr>
+          <a:xfrm>
+            <a:off x="502920" y="347472"/>
+            <a:ext cx="841248" cy="841248"/>
+          </a:xfrm>
+          <a:prstGeom prst="rect">
+            <a:avLst/>
+          </a:prstGeom>
+          <a:noFill/>
+        </p:spPr>
+        <p:txBody>
+          <a:bodyPr wrap="square" anchor="ctr" lIns="0" rIns="0" tIns="0" bIns="0">
+            <a:spAutoFit/>
+          </a:bodyPr>
+          <a:lstStyle/>
+          <a:p>
+            <a:pPr algn="ctr"/>
+            <a:r>
+              <a:rPr sz="3200" b="1" i="0">
+                <a:solidFill>
+                  <a:srgbClr val="FFFFFF"/>
+                </a:solidFill>
+                <a:latin typeface="Segoe UI"/>
+                <a:ea typeface="Microsoft YaHei"/>
+              </a:rPr>
+              <a:t>04</a:t>
+            </a:r>
+          </a:p>
+        </p:txBody>
+      </p:sp>
+      <p:sp>
+        <p:nvSpPr>
+          <p:cNvPr id="5" name="TextBox 4"/>
+          <p:cNvSpPr txBox="1"/>
+          <p:nvPr/>
+        </p:nvSpPr>
+        <p:spPr>
+          <a:xfrm>
+            <a:off x="1536192" y="365760"/>
+            <a:ext cx="10058400" cy="804672"/>
+          </a:xfrm>
+          <a:prstGeom prst="rect">
+            <a:avLst/>
+          </a:prstGeom>
+          <a:noFill/>
+        </p:spPr>
+        <p:txBody>
+          <a:bodyPr wrap="square" lIns="0" rIns="0" anchor="ctr">
+            <a:spAutoFit/>
+          </a:bodyPr>
+          <a:lstStyle/>
+          <a:p>
+            <a:r>
+              <a:rPr sz="2800" b="1" i="0">
+                <a:solidFill>
+                  <a:srgbClr val="DC2626"/>
+                </a:solidFill>
+                <a:latin typeface="Segoe UI"/>
+                <a:ea typeface="Microsoft YaHei"/>
+              </a:rPr>
+              <a:t>What Changes the Plan</a:t>
+            </a:r>
+          </a:p>
+          <a:p>
+            <a:pPr>
+              <a:spcBef>
+                <a:spcPts val="100"/>
+              </a:spcBef>
+            </a:pPr>
+            <a:r>
+              <a:rPr sz="1400" b="0" i="0">
+                <a:solidFill>
+                  <a:srgbClr val="8A97AB"/>
+                </a:solidFill>
+                <a:latin typeface="Microsoft YaHei"/>
+                <a:ea typeface="Microsoft YaHei"/>
+              </a:rPr>
+              <a:t>相对 9 月 9 日计划的变化</a:t>
+            </a:r>
+          </a:p>
+        </p:txBody>
+      </p:sp>
+      <p:sp>
+        <p:nvSpPr>
+          <p:cNvPr id="6" name="Rectangle 5"/>
+          <p:cNvSpPr/>
+          <p:nvPr/>
+        </p:nvSpPr>
+        <p:spPr>
+          <a:xfrm>
+            <a:off x="502920" y="1335024"/>
+            <a:ext cx="11183112" cy="13716"/>
+          </a:xfrm>
+          <a:prstGeom prst="rect">
+            <a:avLst/>
+          </a:prstGeom>
+          <a:solidFill>
+            <a:srgbClr val="E3E8F0"/>
+          </a:solidFill>
+          <a:ln>
+            <a:noFill/>
+          </a:ln>
+          <a:effectLst/>
+        </p:spPr>
+        <p:style>
+          <a:lnRef idx="1">
+            <a:schemeClr val="accent1"/>
+          </a:lnRef>
+          <a:fillRef idx="3">
+            <a:schemeClr val="accent1"/>
+          </a:fillRef>
+          <a:effectRef idx="2">
+            <a:schemeClr val="accent1"/>
+          </a:effectRef>
+          <a:fontRef idx="minor">
+            <a:schemeClr val="lt1"/>
+          </a:fontRef>
+        </p:style>
+        <p:txBody>
+          <a:bodyPr rtlCol="0" anchor="ctr"/>
+          <a:lstStyle/>
+          <a:p>
+            <a:pPr algn="ctr"/>
+          </a:p>
+        </p:txBody>
+      </p:sp>
+      <p:sp>
+        <p:nvSpPr>
+          <p:cNvPr id="7" name="Rounded Rectangle 6"/>
+          <p:cNvSpPr/>
+          <p:nvPr/>
+        </p:nvSpPr>
+        <p:spPr>
+          <a:xfrm>
+            <a:off x="502920" y="1481328"/>
+            <a:ext cx="11183112" cy="1626616"/>
+          </a:xfrm>
+          <a:prstGeom prst="roundRect">
+            <a:avLst/>
+          </a:prstGeom>
+          <a:solidFill>
+            <a:srgbClr val="F4F7FB"/>
+          </a:solidFill>
+          <a:ln w="12700">
+            <a:solidFill>
+              <a:srgbClr val="E3E8F0"/>
+            </a:solidFill>
+          </a:ln>
+          <a:effectLst/>
+        </p:spPr>
+        <p:style>
+          <a:lnRef idx="1">
+            <a:schemeClr val="accent1"/>
+          </a:lnRef>
+          <a:fillRef idx="3">
+            <a:schemeClr val="accent1"/>
+          </a:fillRef>
+          <a:effectRef idx="2">
+            <a:schemeClr val="accent1"/>
+          </a:effectRef>
+          <a:fontRef idx="minor">
+            <a:schemeClr val="lt1"/>
+          </a:fontRef>
+        </p:style>
+        <p:txBody>
+          <a:bodyPr rtlCol="0" anchor="ctr"/>
+          <a:lstStyle/>
+          <a:p>
+            <a:pPr algn="ctr"/>
+          </a:p>
+        </p:txBody>
+      </p:sp>
+      <p:sp>
+        <p:nvSpPr>
+          <p:cNvPr id="8" name="Rectangle 7"/>
+          <p:cNvSpPr/>
+          <p:nvPr/>
+        </p:nvSpPr>
+        <p:spPr>
+          <a:xfrm>
+            <a:off x="502920" y="1481328"/>
+            <a:ext cx="64008" cy="1626616"/>
+          </a:xfrm>
+          <a:prstGeom prst="rect">
+            <a:avLst/>
+          </a:prstGeom>
+          <a:solidFill>
+            <a:srgbClr val="DC2626"/>
+          </a:solidFill>
+          <a:ln>
+            <a:noFill/>
+          </a:ln>
+          <a:effectLst/>
+        </p:spPr>
+        <p:style>
+          <a:lnRef idx="1">
+            <a:schemeClr val="accent1"/>
+          </a:lnRef>
+          <a:fillRef idx="3">
+            <a:schemeClr val="accent1"/>
+          </a:fillRef>
+          <a:effectRef idx="2">
+            <a:schemeClr val="accent1"/>
+          </a:effectRef>
+          <a:fontRef idx="minor">
+            <a:schemeClr val="lt1"/>
+          </a:fontRef>
+        </p:style>
+        <p:txBody>
+          <a:bodyPr rtlCol="0" anchor="ctr"/>
+          <a:lstStyle/>
+          <a:p>
+            <a:pPr algn="ctr"/>
+          </a:p>
+        </p:txBody>
+      </p:sp>
+      <p:sp>
+        <p:nvSpPr>
+          <p:cNvPr id="9" name="TextBox 8"/>
+          <p:cNvSpPr txBox="1"/>
+          <p:nvPr/>
+        </p:nvSpPr>
+        <p:spPr>
+          <a:xfrm>
+            <a:off x="749808" y="1536192"/>
+            <a:ext cx="10744200" cy="1535176"/>
+          </a:xfrm>
+          <a:prstGeom prst="rect">
+            <a:avLst/>
+          </a:prstGeom>
+          <a:noFill/>
+        </p:spPr>
+        <p:txBody>
+          <a:bodyPr wrap="square" lIns="0" rIns="0" tIns="0" bIns="0"/>
+          <a:lstStyle/>
+          <a:p>
+            <a:r>
+              <a:rPr sz="1500" b="1" i="0">
+                <a:solidFill>
+                  <a:srgbClr val="1E2B3A"/>
+                </a:solidFill>
+                <a:latin typeface="Segoe UI"/>
+                <a:ea typeface="Microsoft YaHei"/>
+              </a:rPr>
+              <a:t>Main-equipment enquiry now waits on nozzle orientation and the HTF runs — not on a full drawing sign-off, and not on the UK visit.</a:t>
+            </a:r>
+          </a:p>
+          <a:p>
+            <a:pPr>
+              <a:spcBef>
+                <a:spcPts val="300"/>
+              </a:spcBef>
+            </a:pPr>
+            <a:r>
+              <a:rPr sz="1200" b="0" i="0">
+                <a:solidFill>
+                  <a:srgbClr val="8A97AB"/>
+                </a:solidFill>
+                <a:latin typeface="Microsoft YaHei"/>
+                <a:ea typeface="Microsoft YaHei"/>
+              </a:rPr>
+              <a:t>主设备询价改为等管嘴朝向和 HTF 走向。不等整套图纸签完，也不等赴英。</a:t>
+            </a:r>
+          </a:p>
+          <a:p>
+            <a:pPr>
+              <a:spcBef>
+                <a:spcPts val="600"/>
+              </a:spcBef>
+            </a:pPr>
+            <a:r>
+              <a:rPr sz="1300" b="0" i="0">
+                <a:solidFill>
+                  <a:srgbClr val="94A3B8"/>
+                </a:solidFill>
+                <a:latin typeface="Segoe UI"/>
+                <a:ea typeface="Microsoft YaHei"/>
+              </a:rPr>
+              <a:t>–  </a:t>
+            </a:r>
+            <a:r>
+              <a:rPr sz="1300" b="0" i="0">
+                <a:solidFill>
+                  <a:srgbClr val="3C4A5A"/>
+                </a:solidFill>
+                <a:latin typeface="Segoe UI"/>
+                <a:ea typeface="Microsoft YaHei"/>
+              </a:rPr>
+              <a:t>9 Sep allowed the enquiry once the reactor specification was confirmed.  On 22 Sep Keith would not comment on the 18 Aug drawings until those nozzles are shown to fit.</a:t>
+            </a:r>
+          </a:p>
+          <a:p>
+            <a:pPr>
+              <a:spcBef>
+                <a:spcPts val="100"/>
+              </a:spcBef>
+            </a:pPr>
+            <a:r>
+              <a:rPr sz="1200" b="0" i="0">
+                <a:solidFill>
+                  <a:srgbClr val="8A97AB"/>
+                </a:solidFill>
+                <a:latin typeface="Microsoft YaHei"/>
+                <a:ea typeface="Microsoft YaHei"/>
+              </a:rPr>
+              <a:t>9 月 9 日的口径是反应柱规格确认后即可询价。22 日 Keith 明确：管嘴方向和 HTF 没在模型里站住之前，他不审 8 月 18 日的图。</a:t>
+            </a:r>
+          </a:p>
+        </p:txBody>
+      </p:sp>
+      <p:sp>
+        <p:nvSpPr>
+          <p:cNvPr id="10" name="Rounded Rectangle 9"/>
+          <p:cNvSpPr/>
+          <p:nvPr/>
+        </p:nvSpPr>
+        <p:spPr>
+          <a:xfrm>
+            <a:off x="502920" y="3199384"/>
+            <a:ext cx="11183112" cy="1425194"/>
+          </a:xfrm>
+          <a:prstGeom prst="roundRect">
+            <a:avLst/>
+          </a:prstGeom>
+          <a:solidFill>
+            <a:srgbClr val="F4F7FB"/>
+          </a:solidFill>
+          <a:ln w="12700">
+            <a:solidFill>
+              <a:srgbClr val="E3E8F0"/>
+            </a:solidFill>
+          </a:ln>
+          <a:effectLst/>
+        </p:spPr>
+        <p:style>
+          <a:lnRef idx="1">
+            <a:schemeClr val="accent1"/>
+          </a:lnRef>
+          <a:fillRef idx="3">
+            <a:schemeClr val="accent1"/>
+          </a:fillRef>
+          <a:effectRef idx="2">
+            <a:schemeClr val="accent1"/>
+          </a:effectRef>
+          <a:fontRef idx="minor">
+            <a:schemeClr val="lt1"/>
+          </a:fontRef>
+        </p:style>
+        <p:txBody>
+          <a:bodyPr rtlCol="0" anchor="ctr"/>
+          <a:lstStyle/>
+          <a:p>
+            <a:pPr algn="ctr"/>
+          </a:p>
+        </p:txBody>
+      </p:sp>
+      <p:sp>
+        <p:nvSpPr>
+          <p:cNvPr id="11" name="Rectangle 10"/>
+          <p:cNvSpPr/>
+          <p:nvPr/>
+        </p:nvSpPr>
+        <p:spPr>
+          <a:xfrm>
+            <a:off x="502920" y="3199384"/>
+            <a:ext cx="64008" cy="1425194"/>
+          </a:xfrm>
+          <a:prstGeom prst="rect">
+            <a:avLst/>
+          </a:prstGeom>
+          <a:solidFill>
+            <a:srgbClr val="DC2626"/>
+          </a:solidFill>
+          <a:ln>
+            <a:noFill/>
+          </a:ln>
+          <a:effectLst/>
+        </p:spPr>
+        <p:style>
+          <a:lnRef idx="1">
+            <a:schemeClr val="accent1"/>
+          </a:lnRef>
+          <a:fillRef idx="3">
+            <a:schemeClr val="accent1"/>
+          </a:fillRef>
+          <a:effectRef idx="2">
+            <a:schemeClr val="accent1"/>
+          </a:effectRef>
+          <a:fontRef idx="minor">
+            <a:schemeClr val="lt1"/>
+          </a:fontRef>
+        </p:style>
+        <p:txBody>
+          <a:bodyPr rtlCol="0" anchor="ctr"/>
+          <a:lstStyle/>
+          <a:p>
+            <a:pPr algn="ctr"/>
+          </a:p>
+        </p:txBody>
+      </p:sp>
+      <p:sp>
+        <p:nvSpPr>
+          <p:cNvPr id="12" name="TextBox 11"/>
+          <p:cNvSpPr txBox="1"/>
+          <p:nvPr/>
+        </p:nvSpPr>
+        <p:spPr>
+          <a:xfrm>
+            <a:off x="749808" y="3254248"/>
+            <a:ext cx="10744200" cy="1333754"/>
+          </a:xfrm>
+          <a:prstGeom prst="rect">
+            <a:avLst/>
+          </a:prstGeom>
+          <a:noFill/>
+        </p:spPr>
+        <p:txBody>
+          <a:bodyPr wrap="square" lIns="0" rIns="0" tIns="0" bIns="0"/>
+          <a:lstStyle/>
+          <a:p>
+            <a:r>
+              <a:rPr sz="1500" b="1" i="0">
+                <a:solidFill>
+                  <a:srgbClr val="1E2B3A"/>
+                </a:solidFill>
+                <a:latin typeface="Segoe UI"/>
+                <a:ea typeface="Microsoft YaHei"/>
+              </a:rPr>
+              <a:t>Charging stairs — SW supplies them in the UK, in stainless steel, separate from the main-equipment order.</a:t>
+            </a:r>
+          </a:p>
+          <a:p>
+            <a:pPr>
+              <a:spcBef>
+                <a:spcPts val="300"/>
+              </a:spcBef>
+            </a:pPr>
+            <a:r>
+              <a:rPr sz="1200" b="0" i="0">
+                <a:solidFill>
+                  <a:srgbClr val="8A97AB"/>
+                </a:solidFill>
+                <a:latin typeface="Microsoft YaHei"/>
+                <a:ea typeface="Microsoft YaHei"/>
+              </a:rPr>
+              <a:t>加料梯由 SW 在英国供货，不锈钢，不并进主设备采购。</a:t>
+            </a:r>
+          </a:p>
+          <a:p>
+            <a:pPr>
+              <a:spcBef>
+                <a:spcPts val="600"/>
+              </a:spcBef>
+            </a:pPr>
+            <a:r>
+              <a:rPr sz="1300" b="0" i="0">
+                <a:solidFill>
+                  <a:srgbClr val="94A3B8"/>
+                </a:solidFill>
+                <a:latin typeface="Segoe UI"/>
+                <a:ea typeface="Microsoft YaHei"/>
+              </a:rPr>
+              <a:t>–  </a:t>
+            </a:r>
+            <a:r>
+              <a:rPr sz="1300" b="0" i="0">
+                <a:solidFill>
+                  <a:srgbClr val="3C4A5A"/>
+                </a:solidFill>
+                <a:latin typeface="Segoe UI"/>
+                <a:ea typeface="Microsoft YaHei"/>
+              </a:rPr>
+              <a:t>A catalogue aluminium stair is not acceptable.  China will not design or fabricate this item.  Target height is under 1.4 m.</a:t>
+            </a:r>
+          </a:p>
+          <a:p>
+            <a:pPr>
+              <a:spcBef>
+                <a:spcPts val="100"/>
+              </a:spcBef>
+            </a:pPr>
+            <a:r>
+              <a:rPr sz="1200" b="0" i="0">
+                <a:solidFill>
+                  <a:srgbClr val="8A97AB"/>
+                </a:solidFill>
+                <a:latin typeface="Microsoft YaHei"/>
+                <a:ea typeface="Microsoft YaHei"/>
+              </a:rPr>
+              <a:t>不用成品铝梯。中方不设计、不制造。高度目标低于 1.4 m。</a:t>
+            </a:r>
+          </a:p>
+        </p:txBody>
+      </p:sp>
+      <p:sp>
+        <p:nvSpPr>
+          <p:cNvPr id="13" name="Rounded Rectangle 12"/>
+          <p:cNvSpPr/>
+          <p:nvPr/>
+        </p:nvSpPr>
+        <p:spPr>
+          <a:xfrm>
+            <a:off x="502920" y="4716018"/>
+            <a:ext cx="11183112" cy="1425194"/>
+          </a:xfrm>
+          <a:prstGeom prst="roundRect">
+            <a:avLst/>
+          </a:prstGeom>
+          <a:solidFill>
+            <a:srgbClr val="F4F7FB"/>
+          </a:solidFill>
+          <a:ln w="12700">
+            <a:solidFill>
+              <a:srgbClr val="E3E8F0"/>
+            </a:solidFill>
+          </a:ln>
+          <a:effectLst/>
+        </p:spPr>
+        <p:style>
+          <a:lnRef idx="1">
+            <a:schemeClr val="accent1"/>
+          </a:lnRef>
+          <a:fillRef idx="3">
+            <a:schemeClr val="accent1"/>
+          </a:fillRef>
+          <a:effectRef idx="2">
+            <a:schemeClr val="accent1"/>
+          </a:effectRef>
+          <a:fontRef idx="minor">
+            <a:schemeClr val="lt1"/>
+          </a:fontRef>
+        </p:style>
+        <p:txBody>
+          <a:bodyPr rtlCol="0" anchor="ctr"/>
+          <a:lstStyle/>
+          <a:p>
+            <a:pPr algn="ctr"/>
+          </a:p>
+        </p:txBody>
+      </p:sp>
+      <p:sp>
+        <p:nvSpPr>
+          <p:cNvPr id="14" name="Rectangle 13"/>
+          <p:cNvSpPr/>
+          <p:nvPr/>
+        </p:nvSpPr>
+        <p:spPr>
+          <a:xfrm>
+            <a:off x="502920" y="4716018"/>
+            <a:ext cx="64008" cy="1425194"/>
+          </a:xfrm>
+          <a:prstGeom prst="rect">
+            <a:avLst/>
+          </a:prstGeom>
+          <a:solidFill>
+            <a:srgbClr val="DC2626"/>
+          </a:solidFill>
+          <a:ln>
+            <a:noFill/>
+          </a:ln>
+          <a:effectLst/>
+        </p:spPr>
+        <p:style>
+          <a:lnRef idx="1">
+            <a:schemeClr val="accent1"/>
+          </a:lnRef>
+          <a:fillRef idx="3">
+            <a:schemeClr val="accent1"/>
+          </a:fillRef>
+          <a:effectRef idx="2">
+            <a:schemeClr val="accent1"/>
+          </a:effectRef>
+          <a:fontRef idx="minor">
+            <a:schemeClr val="lt1"/>
+          </a:fontRef>
+        </p:style>
+        <p:txBody>
+          <a:bodyPr rtlCol="0" anchor="ctr"/>
+          <a:lstStyle/>
+          <a:p>
+            <a:pPr algn="ctr"/>
+          </a:p>
+        </p:txBody>
+      </p:sp>
+      <p:sp>
+        <p:nvSpPr>
+          <p:cNvPr id="15" name="TextBox 14"/>
+          <p:cNvSpPr txBox="1"/>
+          <p:nvPr/>
+        </p:nvSpPr>
+        <p:spPr>
+          <a:xfrm>
+            <a:off x="749808" y="4770882"/>
+            <a:ext cx="10744200" cy="1333754"/>
+          </a:xfrm>
+          <a:prstGeom prst="rect">
+            <a:avLst/>
+          </a:prstGeom>
+          <a:noFill/>
+        </p:spPr>
+        <p:txBody>
+          <a:bodyPr wrap="square" lIns="0" rIns="0" tIns="0" bIns="0"/>
+          <a:lstStyle/>
+          <a:p>
+            <a:r>
+              <a:rPr sz="1500" b="1" i="0">
+                <a:solidFill>
+                  <a:srgbClr val="1E2B3A"/>
+                </a:solidFill>
+                <a:latin typeface="Segoe UI"/>
+                <a:ea typeface="Microsoft YaHei"/>
+              </a:rPr>
+              <a:t>12–22 October is still the proposed visit.  It is not confirmed.  An early-November window is being checked.</a:t>
+            </a:r>
+          </a:p>
+          <a:p>
+            <a:pPr>
+              <a:spcBef>
+                <a:spcPts val="300"/>
+              </a:spcBef>
+            </a:pPr>
+            <a:r>
+              <a:rPr sz="1200" b="0" i="0">
+                <a:solidFill>
+                  <a:srgbClr val="8A97AB"/>
+                </a:solidFill>
+                <a:latin typeface="Microsoft YaHei"/>
+                <a:ea typeface="Microsoft YaHei"/>
+              </a:rPr>
+              <a:t>10 月 12–22 日仍是建议行程，尚未确认。11 月初的备选窗口正在核实。</a:t>
+            </a:r>
+          </a:p>
+          <a:p>
+            <a:pPr>
+              <a:spcBef>
+                <a:spcPts val="600"/>
+              </a:spcBef>
+            </a:pPr>
+            <a:r>
+              <a:rPr sz="1300" b="0" i="0">
+                <a:solidFill>
+                  <a:srgbClr val="94A3B8"/>
+                </a:solidFill>
+                <a:latin typeface="Segoe UI"/>
+                <a:ea typeface="Microsoft YaHei"/>
+              </a:rPr>
+              <a:t>–  </a:t>
+            </a:r>
+            <a:r>
+              <a:rPr sz="1300" b="0" i="0">
+                <a:solidFill>
+                  <a:srgbClr val="3C4A5A"/>
+                </a:solidFill>
+                <a:latin typeface="Segoe UI"/>
+                <a:ea typeface="Microsoft YaHei"/>
+              </a:rPr>
+              <a:t>The model work this week does not wait for that confirmation.</a:t>
+            </a:r>
+          </a:p>
+          <a:p>
+            <a:pPr>
+              <a:spcBef>
+                <a:spcPts val="100"/>
+              </a:spcBef>
+            </a:pPr>
+            <a:r>
+              <a:rPr sz="1200" b="0" i="0">
+                <a:solidFill>
+                  <a:srgbClr val="8A97AB"/>
+                </a:solidFill>
+                <a:latin typeface="Microsoft YaHei"/>
+                <a:ea typeface="Microsoft YaHei"/>
+              </a:rPr>
+              <a:t>本周的模型工作不等这个日期。</a:t>
+            </a:r>
+          </a:p>
+        </p:txBody>
+      </p:sp>
+      <p:sp>
+        <p:nvSpPr>
+          <p:cNvPr id="16" name="TextBox 15"/>
+          <p:cNvSpPr txBox="1"/>
+          <p:nvPr/>
+        </p:nvSpPr>
+        <p:spPr>
+          <a:xfrm>
+            <a:off x="548640" y="6446520"/>
+            <a:ext cx="6583680" cy="274320"/>
+          </a:xfrm>
+          <a:prstGeom prst="rect">
+            <a:avLst/>
+          </a:prstGeom>
+          <a:noFill/>
+        </p:spPr>
+        <p:txBody>
+          <a:bodyPr wrap="none">
+            <a:spAutoFit/>
+          </a:bodyPr>
+          <a:lstStyle/>
+          <a:p>
+            <a:r>
+              <a:rPr sz="900" b="0" i="0">
+                <a:solidFill>
+                  <a:srgbClr val="9AA6B8"/>
+                </a:solidFill>
+                <a:latin typeface="Segoe UI"/>
+                <a:ea typeface="Microsoft YaHei"/>
+              </a:rPr>
+              <a:t>Asymchem · Sandwich Site   |   Continuous Hydrogenation Skid</a:t>
+            </a:r>
+          </a:p>
+        </p:txBody>
+      </p:sp>
+      <p:sp>
+        <p:nvSpPr>
+          <p:cNvPr id="17" name="TextBox 16"/>
+          <p:cNvSpPr txBox="1"/>
+          <p:nvPr/>
+        </p:nvSpPr>
+        <p:spPr>
+          <a:xfrm>
+            <a:off x="6949440" y="6446520"/>
+            <a:ext cx="4663440" cy="274320"/>
+          </a:xfrm>
+          <a:prstGeom prst="rect">
+            <a:avLst/>
+          </a:prstGeom>
+          <a:noFill/>
+        </p:spPr>
+        <p:txBody>
+          <a:bodyPr wrap="none">
+            <a:spAutoFit/>
+          </a:bodyPr>
+          <a:lstStyle/>
+          <a:p>
+            <a:pPr algn="r"/>
+            <a:r>
+              <a:rPr sz="900" b="0" i="0">
+                <a:solidFill>
+                  <a:srgbClr val="9AA6B8"/>
+                </a:solidFill>
+                <a:latin typeface="Segoe UI"/>
+                <a:ea typeface="Microsoft YaHei"/>
+              </a:rPr>
+              <a:t>Bi-weekly Progress 2026-09-09 ~ 09-23    ·    04 / 05</a:t>
+            </a:r>
+          </a:p>
+        </p:txBody>
+      </p:sp>
+    </p:spTree>
+  </p:cSld>
+  <p:clrMapOvr>
+    <a:masterClrMapping/>
+  </p:clrMapOvr>
+</p:sld>
+</file>
+
+<file path=ppt/slides/slide5.xml><?xml version="1.0" encoding="utf-8"?>
+<p:sld xmlns:a="http://schemas.openxmlformats.org/drawingml/2006/main" xmlns:p="http://schemas.openxmlformats.org/presentationml/2006/main" xmlns:r="http://schemas.openxmlformats.org/officeDocument/2006/relationships">
+  <p:cSld>
+    <p:spTree>
+      <p:nvGrpSpPr>
+        <p:cNvPr id="1" name=""/>
+        <p:cNvGrpSpPr/>
+        <p:nvPr/>
+      </p:nvGrpSpPr>
+      <p:grpSpPr/>
+      <p:sp>
+        <p:nvSpPr>
+          <p:cNvPr id="2" name="Rectangle 1"/>
+          <p:cNvSpPr/>
+          <p:nvPr/>
+        </p:nvSpPr>
+        <p:spPr>
+          <a:xfrm>
+            <a:off x="0" y="0"/>
+            <a:ext cx="12191695" cy="146304"/>
+          </a:xfrm>
+          <a:prstGeom prst="rect">
             <a:avLst/>
           </a:prstGeom>
           <a:solidFill>
@@ -5164,6 +6406,50 @@
       </p:sp>
       <p:sp>
         <p:nvSpPr>
+          <p:cNvPr id="3" name="Rounded Rectangle 2"/>
+          <p:cNvSpPr/>
+          <p:nvPr/>
+        </p:nvSpPr>
+        <p:spPr>
+          <a:xfrm>
+            <a:off x="502920" y="347472"/>
+            <a:ext cx="841248" cy="841248"/>
+          </a:xfrm>
+          <a:prstGeom prst="roundRect">
+            <a:avLst/>
+          </a:prstGeom>
+          <a:solidFill>
+            <a:srgbClr val="0E9AA7"/>
+          </a:solidFill>
+          <a:ln>
+            <a:noFill/>
+          </a:ln>
+          <a:effectLst/>
+        </p:spPr>
+        <p:style>
+          <a:lnRef idx="1">
+            <a:schemeClr val="accent1"/>
+          </a:lnRef>
+          <a:fillRef idx="3">
+            <a:schemeClr val="accent1"/>
+          </a:fillRef>
+          <a:effectRef idx="2">
+            <a:schemeClr val="accent1"/>
+          </a:effectRef>
+          <a:fontRef idx="minor">
+            <a:schemeClr val="lt1"/>
+          </a:fontRef>
+        </p:style>
+        <p:txBody>
+          <a:bodyPr rtlCol="0" anchor="ctr"/>
+          <a:lstStyle/>
+          <a:p>
+            <a:pPr algn="ctr"/>
+          </a:p>
+        </p:txBody>
+      </p:sp>
+      <p:sp>
+        <p:nvSpPr>
           <p:cNvPr id="4" name="TextBox 3"/>
           <p:cNvSpPr txBox="1"/>
           <p:nvPr/>
@@ -5193,7 +6479,7 @@
                 <a:latin typeface="Segoe UI"/>
                 <a:ea typeface="Microsoft YaHei"/>
               </a:rPr>
-              <a:t>04</a:t>
+              <a:t>05</a:t>
             </a:r>
           </a:p>
         </p:txBody>
@@ -5296,14 +6582,104 @@
       </p:sp>
       <p:sp>
         <p:nvSpPr>
-          <p:cNvPr id="7" name="TextBox 6"/>
+          <p:cNvPr id="7" name="Rounded Rectangle 6"/>
+          <p:cNvSpPr/>
+          <p:nvPr/>
+        </p:nvSpPr>
+        <p:spPr>
+          <a:xfrm>
+            <a:off x="502920" y="1481328"/>
+            <a:ext cx="11183112" cy="703326"/>
+          </a:xfrm>
+          <a:prstGeom prst="roundRect">
+            <a:avLst/>
+          </a:prstGeom>
+          <a:solidFill>
+            <a:srgbClr val="F4F7FB"/>
+          </a:solidFill>
+          <a:ln w="12700">
+            <a:solidFill>
+              <a:srgbClr val="E3E8F0"/>
+            </a:solidFill>
+          </a:ln>
+          <a:effectLst/>
+        </p:spPr>
+        <p:style>
+          <a:lnRef idx="1">
+            <a:schemeClr val="accent1"/>
+          </a:lnRef>
+          <a:fillRef idx="3">
+            <a:schemeClr val="accent1"/>
+          </a:fillRef>
+          <a:effectRef idx="2">
+            <a:schemeClr val="accent1"/>
+          </a:effectRef>
+          <a:fontRef idx="minor">
+            <a:schemeClr val="lt1"/>
+          </a:fontRef>
+        </p:style>
+        <p:txBody>
+          <a:bodyPr rtlCol="0" anchor="ctr"/>
+          <a:lstStyle/>
+          <a:p>
+            <a:pPr algn="ctr"/>
+          </a:p>
+        </p:txBody>
+      </p:sp>
+      <p:sp>
+        <p:nvSpPr>
+          <p:cNvPr id="8" name="Rectangle 7"/>
+          <p:cNvSpPr/>
+          <p:nvPr/>
+        </p:nvSpPr>
+        <p:spPr>
+          <a:xfrm>
+            <a:off x="502920" y="1481328"/>
+            <a:ext cx="64008" cy="703326"/>
+          </a:xfrm>
+          <a:prstGeom prst="rect">
+            <a:avLst/>
+          </a:prstGeom>
+          <a:solidFill>
+            <a:srgbClr val="0E9AA7"/>
+          </a:solidFill>
+          <a:ln>
+            <a:noFill/>
+          </a:ln>
+          <a:effectLst/>
+        </p:spPr>
+        <p:style>
+          <a:lnRef idx="1">
+            <a:schemeClr val="accent1"/>
+          </a:lnRef>
+          <a:fillRef idx="3">
+            <a:schemeClr val="accent1"/>
+          </a:fillRef>
+          <a:effectRef idx="2">
+            <a:schemeClr val="accent1"/>
+          </a:effectRef>
+          <a:fontRef idx="minor">
+            <a:schemeClr val="lt1"/>
+          </a:fontRef>
+        </p:style>
+        <p:txBody>
+          <a:bodyPr rtlCol="0" anchor="ctr"/>
+          <a:lstStyle/>
+          <a:p>
+            <a:pPr algn="ctr"/>
+          </a:p>
+        </p:txBody>
+      </p:sp>
+      <p:sp>
+        <p:nvSpPr>
+          <p:cNvPr id="9" name="TextBox 8"/>
           <p:cNvSpPr txBox="1"/>
           <p:nvPr/>
         </p:nvSpPr>
         <p:spPr>
           <a:xfrm>
-            <a:off x="566928" y="1481328"/>
-            <a:ext cx="11064240" cy="438912"/>
+            <a:off x="749808" y="1536192"/>
+            <a:ext cx="10744200" cy="611886"/>
           </a:xfrm>
           <a:prstGeom prst="rect">
             <a:avLst/>
@@ -5311,61 +6687,139 @@
           <a:noFill/>
         </p:spPr>
         <p:txBody>
-          <a:bodyPr wrap="square" lIns="0" rIns="0">
-            <a:spAutoFit/>
-          </a:bodyPr>
-          <a:lstStyle/>
-          <a:p>
-            <a:r>
-              <a:rPr sz="1600" b="1" i="0">
-                <a:solidFill>
-                  <a:srgbClr val="0E9AA7"/>
+          <a:bodyPr wrap="square" lIns="0" rIns="0" tIns="0" bIns="0"/>
+          <a:lstStyle/>
+          <a:p>
+            <a:r>
+              <a:rPr sz="1500" b="1" i="0">
+                <a:solidFill>
+                  <a:srgbClr val="1E2B3A"/>
                 </a:solidFill>
                 <a:latin typeface="Segoe UI"/>
                 <a:ea typeface="Microsoft YaHei"/>
               </a:rPr>
-              <a:t>●  </a:t>
-            </a:r>
-            <a:r>
-              <a:rPr sz="1600" b="1" i="0">
-                <a:solidFill>
-                  <a:srgbClr val="1E2B3A"/>
-                </a:solidFill>
-                <a:latin typeface="Segoe UI"/>
-                <a:ea typeface="Microsoft YaHei"/>
-              </a:rPr>
-              <a:t>Fan — draw both layouts, turn the reactor-3 nozzle toward the wall riser, and place drain / CIP valves at the tee.</a:t>
+              <a:t>Fan — both layouts; reactor-3 nozzle toward the wall riser; drain and CIP valves at the tee.</a:t>
             </a:r>
           </a:p>
           <a:p>
             <a:pPr>
               <a:spcBef>
-                <a:spcPts val="100"/>
+                <a:spcPts val="300"/>
               </a:spcBef>
             </a:pPr>
             <a:r>
-              <a:rPr sz="1150" b="0" i="0">
+              <a:rPr sz="1200" b="0" i="0">
                 <a:solidFill>
                   <a:srgbClr val="8A97AB"/>
                 </a:solidFill>
                 <a:latin typeface="Microsoft YaHei"/>
                 <a:ea typeface="Microsoft YaHei"/>
               </a:rPr>
-              <a:t>     范双双：两版布置都画出来；反应器 3 管嘴朝向穿墙立管；排净 / CIP 阀放到三通处。</a:t>
-            </a:r>
-          </a:p>
-        </p:txBody>
-      </p:sp>
-      <p:sp>
-        <p:nvSpPr>
-          <p:cNvPr id="8" name="TextBox 7"/>
+              <a:t>范双双：两版布置、反应器 3 管嘴朝向穿墙立管、排净和 CIP 阀放在三通处。</a:t>
+            </a:r>
+          </a:p>
+        </p:txBody>
+      </p:sp>
+      <p:sp>
+        <p:nvSpPr>
+          <p:cNvPr id="10" name="Rounded Rectangle 9"/>
+          <p:cNvSpPr/>
+          <p:nvPr/>
+        </p:nvSpPr>
+        <p:spPr>
+          <a:xfrm>
+            <a:off x="502920" y="2276094"/>
+            <a:ext cx="11183112" cy="703326"/>
+          </a:xfrm>
+          <a:prstGeom prst="roundRect">
+            <a:avLst/>
+          </a:prstGeom>
+          <a:solidFill>
+            <a:srgbClr val="F4F7FB"/>
+          </a:solidFill>
+          <a:ln w="12700">
+            <a:solidFill>
+              <a:srgbClr val="E3E8F0"/>
+            </a:solidFill>
+          </a:ln>
+          <a:effectLst/>
+        </p:spPr>
+        <p:style>
+          <a:lnRef idx="1">
+            <a:schemeClr val="accent1"/>
+          </a:lnRef>
+          <a:fillRef idx="3">
+            <a:schemeClr val="accent1"/>
+          </a:fillRef>
+          <a:effectRef idx="2">
+            <a:schemeClr val="accent1"/>
+          </a:effectRef>
+          <a:fontRef idx="minor">
+            <a:schemeClr val="lt1"/>
+          </a:fontRef>
+        </p:style>
+        <p:txBody>
+          <a:bodyPr rtlCol="0" anchor="ctr"/>
+          <a:lstStyle/>
+          <a:p>
+            <a:pPr algn="ctr"/>
+          </a:p>
+        </p:txBody>
+      </p:sp>
+      <p:sp>
+        <p:nvSpPr>
+          <p:cNvPr id="11" name="Rectangle 10"/>
+          <p:cNvSpPr/>
+          <p:nvPr/>
+        </p:nvSpPr>
+        <p:spPr>
+          <a:xfrm>
+            <a:off x="502920" y="2276094"/>
+            <a:ext cx="64008" cy="703326"/>
+          </a:xfrm>
+          <a:prstGeom prst="rect">
+            <a:avLst/>
+          </a:prstGeom>
+          <a:solidFill>
+            <a:srgbClr val="0E9AA7"/>
+          </a:solidFill>
+          <a:ln>
+            <a:noFill/>
+          </a:ln>
+          <a:effectLst/>
+        </p:spPr>
+        <p:style>
+          <a:lnRef idx="1">
+            <a:schemeClr val="accent1"/>
+          </a:lnRef>
+          <a:fillRef idx="3">
+            <a:schemeClr val="accent1"/>
+          </a:fillRef>
+          <a:effectRef idx="2">
+            <a:schemeClr val="accent1"/>
+          </a:effectRef>
+          <a:fontRef idx="minor">
+            <a:schemeClr val="lt1"/>
+          </a:fontRef>
+        </p:style>
+        <p:txBody>
+          <a:bodyPr rtlCol="0" anchor="ctr"/>
+          <a:lstStyle/>
+          <a:p>
+            <a:pPr algn="ctr"/>
+          </a:p>
+        </p:txBody>
+      </p:sp>
+      <p:sp>
+        <p:nvSpPr>
+          <p:cNvPr id="12" name="TextBox 11"/>
           <p:cNvSpPr txBox="1"/>
           <p:nvPr/>
         </p:nvSpPr>
         <p:spPr>
           <a:xfrm>
-            <a:off x="566928" y="1975104"/>
-            <a:ext cx="11064240" cy="438912"/>
+            <a:off x="749808" y="2330958"/>
+            <a:ext cx="10744200" cy="611886"/>
           </a:xfrm>
           <a:prstGeom prst="rect">
             <a:avLst/>
@@ -5373,61 +6827,139 @@
           <a:noFill/>
         </p:spPr>
         <p:txBody>
-          <a:bodyPr wrap="square" lIns="0" rIns="0">
-            <a:spAutoFit/>
-          </a:bodyPr>
-          <a:lstStyle/>
-          <a:p>
-            <a:r>
-              <a:rPr sz="1600" b="1" i="0">
-                <a:solidFill>
-                  <a:srgbClr val="0E9AA7"/>
+          <a:bodyPr wrap="square" lIns="0" rIns="0" tIns="0" bIns="0"/>
+          <a:lstStyle/>
+          <a:p>
+            <a:r>
+              <a:rPr sz="1500" b="1" i="0">
+                <a:solidFill>
+                  <a:srgbClr val="1E2B3A"/>
                 </a:solidFill>
                 <a:latin typeface="Segoe UI"/>
                 <a:ea typeface="Microsoft YaHei"/>
               </a:rPr>
-              <a:t>●  </a:t>
-            </a:r>
-            <a:r>
-              <a:rPr sz="1600" b="1" i="0">
-                <a:solidFill>
-                  <a:srgbClr val="1E2B3A"/>
-                </a:solidFill>
-                <a:latin typeface="Segoe UI"/>
-                <a:ea typeface="Microsoft YaHei"/>
-              </a:rPr>
-              <a:t>Gao Yu — Habonim ball valve and actuator envelope to Fan, and whether it can be bought in China.</a:t>
+              <a:t>Gao Yu — Habonim valve and actuator envelope to Fan, and whether China can buy it.</a:t>
             </a:r>
           </a:p>
           <a:p>
             <a:pPr>
               <a:spcBef>
-                <a:spcPts val="100"/>
+                <a:spcPts val="300"/>
               </a:spcBef>
             </a:pPr>
             <a:r>
-              <a:rPr sz="1150" b="0" i="0">
+              <a:rPr sz="1200" b="0" i="0">
                 <a:solidFill>
                   <a:srgbClr val="8A97AB"/>
                 </a:solidFill>
                 <a:latin typeface="Microsoft YaHei"/>
                 <a:ea typeface="Microsoft YaHei"/>
               </a:rPr>
-              <a:t>     高宇：把 Habonim 球阀和气动头的外形给范双双，并确认国内能否买到。</a:t>
-            </a:r>
-          </a:p>
-        </p:txBody>
-      </p:sp>
-      <p:sp>
-        <p:nvSpPr>
-          <p:cNvPr id="9" name="TextBox 8"/>
+              <a:t>高宇：Habonim 阀和气动头外形交给范双双，并确认国内能否采购。</a:t>
+            </a:r>
+          </a:p>
+        </p:txBody>
+      </p:sp>
+      <p:sp>
+        <p:nvSpPr>
+          <p:cNvPr id="13" name="Rounded Rectangle 12"/>
+          <p:cNvSpPr/>
+          <p:nvPr/>
+        </p:nvSpPr>
+        <p:spPr>
+          <a:xfrm>
+            <a:off x="502920" y="3070860"/>
+            <a:ext cx="11183112" cy="703326"/>
+          </a:xfrm>
+          <a:prstGeom prst="roundRect">
+            <a:avLst/>
+          </a:prstGeom>
+          <a:solidFill>
+            <a:srgbClr val="F4F7FB"/>
+          </a:solidFill>
+          <a:ln w="12700">
+            <a:solidFill>
+              <a:srgbClr val="E3E8F0"/>
+            </a:solidFill>
+          </a:ln>
+          <a:effectLst/>
+        </p:spPr>
+        <p:style>
+          <a:lnRef idx="1">
+            <a:schemeClr val="accent1"/>
+          </a:lnRef>
+          <a:fillRef idx="3">
+            <a:schemeClr val="accent1"/>
+          </a:fillRef>
+          <a:effectRef idx="2">
+            <a:schemeClr val="accent1"/>
+          </a:effectRef>
+          <a:fontRef idx="minor">
+            <a:schemeClr val="lt1"/>
+          </a:fontRef>
+        </p:style>
+        <p:txBody>
+          <a:bodyPr rtlCol="0" anchor="ctr"/>
+          <a:lstStyle/>
+          <a:p>
+            <a:pPr algn="ctr"/>
+          </a:p>
+        </p:txBody>
+      </p:sp>
+      <p:sp>
+        <p:nvSpPr>
+          <p:cNvPr id="14" name="Rectangle 13"/>
+          <p:cNvSpPr/>
+          <p:nvPr/>
+        </p:nvSpPr>
+        <p:spPr>
+          <a:xfrm>
+            <a:off x="502920" y="3070860"/>
+            <a:ext cx="64008" cy="703326"/>
+          </a:xfrm>
+          <a:prstGeom prst="rect">
+            <a:avLst/>
+          </a:prstGeom>
+          <a:solidFill>
+            <a:srgbClr val="0E9AA7"/>
+          </a:solidFill>
+          <a:ln>
+            <a:noFill/>
+          </a:ln>
+          <a:effectLst/>
+        </p:spPr>
+        <p:style>
+          <a:lnRef idx="1">
+            <a:schemeClr val="accent1"/>
+          </a:lnRef>
+          <a:fillRef idx="3">
+            <a:schemeClr val="accent1"/>
+          </a:fillRef>
+          <a:effectRef idx="2">
+            <a:schemeClr val="accent1"/>
+          </a:effectRef>
+          <a:fontRef idx="minor">
+            <a:schemeClr val="lt1"/>
+          </a:fontRef>
+        </p:style>
+        <p:txBody>
+          <a:bodyPr rtlCol="0" anchor="ctr"/>
+          <a:lstStyle/>
+          <a:p>
+            <a:pPr algn="ctr"/>
+          </a:p>
+        </p:txBody>
+      </p:sp>
+      <p:sp>
+        <p:nvSpPr>
+          <p:cNvPr id="15" name="TextBox 14"/>
           <p:cNvSpPr txBox="1"/>
           <p:nvPr/>
         </p:nvSpPr>
         <p:spPr>
           <a:xfrm>
-            <a:off x="566928" y="2468880"/>
-            <a:ext cx="11064240" cy="438912"/>
+            <a:off x="749808" y="3125724"/>
+            <a:ext cx="10744200" cy="611886"/>
           </a:xfrm>
           <a:prstGeom prst="rect">
             <a:avLst/>
@@ -5435,61 +6967,139 @@
           <a:noFill/>
         </p:spPr>
         <p:txBody>
-          <a:bodyPr wrap="square" lIns="0" rIns="0">
-            <a:spAutoFit/>
-          </a:bodyPr>
-          <a:lstStyle/>
-          <a:p>
-            <a:r>
-              <a:rPr sz="1600" b="1" i="0">
-                <a:solidFill>
-                  <a:srgbClr val="0E9AA7"/>
+          <a:bodyPr wrap="square" lIns="0" rIns="0" tIns="0" bIns="0"/>
+          <a:lstStyle/>
+          <a:p>
+            <a:r>
+              <a:rPr sz="1500" b="1" i="0">
+                <a:solidFill>
+                  <a:srgbClr val="1E2B3A"/>
                 </a:solidFill>
                 <a:latin typeface="Segoe UI"/>
                 <a:ea typeface="Microsoft YaHei"/>
               </a:rPr>
-              <a:t>●  </a:t>
-            </a:r>
-            <a:r>
-              <a:rPr sz="1600" b="1" i="0">
-                <a:solidFill>
-                  <a:srgbClr val="1E2B3A"/>
-                </a:solidFill>
-                <a:latin typeface="Segoe UI"/>
-                <a:ea typeface="Microsoft YaHei"/>
-              </a:rPr>
-              <a:t>Meng — which signals stay on the pull-out module, and which still leave it.  Cable count waits on the junction-box size.</a:t>
+              <a:t>Meng — which signals stay on the pull-out module. Cable count waits on the junction box.</a:t>
             </a:r>
           </a:p>
           <a:p>
             <a:pPr>
               <a:spcBef>
-                <a:spcPts val="100"/>
+                <a:spcPts val="300"/>
               </a:spcBef>
             </a:pPr>
             <a:r>
-              <a:rPr sz="1150" b="0" i="0">
+              <a:rPr sz="1200" b="0" i="0">
                 <a:solidFill>
                   <a:srgbClr val="8A97AB"/>
                 </a:solidFill>
                 <a:latin typeface="Microsoft YaHei"/>
                 <a:ea typeface="Microsoft YaHei"/>
               </a:rPr>
-              <a:t>     孟德智：可拉出模块上哪些信号留在本撬、哪些还要外引。电缆数量等接线箱尺寸。</a:t>
-            </a:r>
-          </a:p>
-        </p:txBody>
-      </p:sp>
-      <p:sp>
-        <p:nvSpPr>
-          <p:cNvPr id="10" name="TextBox 9"/>
+              <a:t>孟德智：列出可拉出模块上留下的信号。电缆数量等接线箱尺寸。</a:t>
+            </a:r>
+          </a:p>
+        </p:txBody>
+      </p:sp>
+      <p:sp>
+        <p:nvSpPr>
+          <p:cNvPr id="16" name="Rounded Rectangle 15"/>
+          <p:cNvSpPr/>
+          <p:nvPr/>
+        </p:nvSpPr>
+        <p:spPr>
+          <a:xfrm>
+            <a:off x="502920" y="3865626"/>
+            <a:ext cx="11183112" cy="703326"/>
+          </a:xfrm>
+          <a:prstGeom prst="roundRect">
+            <a:avLst/>
+          </a:prstGeom>
+          <a:solidFill>
+            <a:srgbClr val="F4F7FB"/>
+          </a:solidFill>
+          <a:ln w="12700">
+            <a:solidFill>
+              <a:srgbClr val="E3E8F0"/>
+            </a:solidFill>
+          </a:ln>
+          <a:effectLst/>
+        </p:spPr>
+        <p:style>
+          <a:lnRef idx="1">
+            <a:schemeClr val="accent1"/>
+          </a:lnRef>
+          <a:fillRef idx="3">
+            <a:schemeClr val="accent1"/>
+          </a:fillRef>
+          <a:effectRef idx="2">
+            <a:schemeClr val="accent1"/>
+          </a:effectRef>
+          <a:fontRef idx="minor">
+            <a:schemeClr val="lt1"/>
+          </a:fontRef>
+        </p:style>
+        <p:txBody>
+          <a:bodyPr rtlCol="0" anchor="ctr"/>
+          <a:lstStyle/>
+          <a:p>
+            <a:pPr algn="ctr"/>
+          </a:p>
+        </p:txBody>
+      </p:sp>
+      <p:sp>
+        <p:nvSpPr>
+          <p:cNvPr id="17" name="Rectangle 16"/>
+          <p:cNvSpPr/>
+          <p:nvPr/>
+        </p:nvSpPr>
+        <p:spPr>
+          <a:xfrm>
+            <a:off x="502920" y="3865626"/>
+            <a:ext cx="64008" cy="703326"/>
+          </a:xfrm>
+          <a:prstGeom prst="rect">
+            <a:avLst/>
+          </a:prstGeom>
+          <a:solidFill>
+            <a:srgbClr val="0E9AA7"/>
+          </a:solidFill>
+          <a:ln>
+            <a:noFill/>
+          </a:ln>
+          <a:effectLst/>
+        </p:spPr>
+        <p:style>
+          <a:lnRef idx="1">
+            <a:schemeClr val="accent1"/>
+          </a:lnRef>
+          <a:fillRef idx="3">
+            <a:schemeClr val="accent1"/>
+          </a:fillRef>
+          <a:effectRef idx="2">
+            <a:schemeClr val="accent1"/>
+          </a:effectRef>
+          <a:fontRef idx="minor">
+            <a:schemeClr val="lt1"/>
+          </a:fontRef>
+        </p:style>
+        <p:txBody>
+          <a:bodyPr rtlCol="0" anchor="ctr"/>
+          <a:lstStyle/>
+          <a:p>
+            <a:pPr algn="ctr"/>
+          </a:p>
+        </p:txBody>
+      </p:sp>
+      <p:sp>
+        <p:nvSpPr>
+          <p:cNvPr id="18" name="TextBox 17"/>
           <p:cNvSpPr txBox="1"/>
           <p:nvPr/>
         </p:nvSpPr>
         <p:spPr>
           <a:xfrm>
-            <a:off x="566928" y="2962656"/>
-            <a:ext cx="11064240" cy="438912"/>
+            <a:off x="749808" y="3920489"/>
+            <a:ext cx="10744200" cy="611886"/>
           </a:xfrm>
           <a:prstGeom prst="rect">
             <a:avLst/>
@@ -5497,61 +7107,139 @@
           <a:noFill/>
         </p:spPr>
         <p:txBody>
-          <a:bodyPr wrap="square" lIns="0" rIns="0">
-            <a:spAutoFit/>
-          </a:bodyPr>
-          <a:lstStyle/>
-          <a:p>
-            <a:r>
-              <a:rPr sz="1600" b="1" i="0">
-                <a:solidFill>
-                  <a:srgbClr val="0E9AA7"/>
+          <a:bodyPr wrap="square" lIns="0" rIns="0" tIns="0" bIns="0"/>
+          <a:lstStyle/>
+          <a:p>
+            <a:r>
+              <a:rPr sz="1500" b="1" i="0">
+                <a:solidFill>
+                  <a:srgbClr val="1E2B3A"/>
                 </a:solidFill>
                 <a:latin typeface="Segoe UI"/>
                 <a:ea typeface="Microsoft YaHei"/>
               </a:rPr>
-              <a:t>●  </a:t>
-            </a:r>
-            <a:r>
-              <a:rPr sz="1600" b="1" i="0">
-                <a:solidFill>
-                  <a:srgbClr val="1E2B3A"/>
-                </a:solidFill>
-                <a:latin typeface="Segoe UI"/>
-                <a:ea typeface="Microsoft YaHei"/>
-              </a:rPr>
-              <a:t>Keith — send the NWD model; junction-box feedback by 25 or 28 Sep; valve tidy-up once the layout is close.</a:t>
+              <a:t>Keith — send the NWD; junction-box size by 25 or 28 Sep; tidy valves when the layout is close.</a:t>
             </a:r>
           </a:p>
           <a:p>
             <a:pPr>
               <a:spcBef>
-                <a:spcPts val="100"/>
+                <a:spcPts val="300"/>
               </a:spcBef>
             </a:pPr>
             <a:r>
-              <a:rPr sz="1150" b="0" i="0">
+              <a:rPr sz="1200" b="0" i="0">
                 <a:solidFill>
                   <a:srgbClr val="8A97AB"/>
                 </a:solidFill>
                 <a:latin typeface="Microsoft YaHei"/>
                 <a:ea typeface="Microsoft YaHei"/>
               </a:rPr>
-              <a:t>     Keith：发 NWD；接线箱 9 月 25 日或 28 日反馈；布置接近后再精简阀门。</a:t>
-            </a:r>
-          </a:p>
-        </p:txBody>
-      </p:sp>
-      <p:sp>
-        <p:nvSpPr>
-          <p:cNvPr id="11" name="TextBox 10"/>
+              <a:t>Keith：发送 NWD；9 月 25 日或 28 日反馈接线箱；布置接近后精简阀门。</a:t>
+            </a:r>
+          </a:p>
+        </p:txBody>
+      </p:sp>
+      <p:sp>
+        <p:nvSpPr>
+          <p:cNvPr id="19" name="Rounded Rectangle 18"/>
+          <p:cNvSpPr/>
+          <p:nvPr/>
+        </p:nvSpPr>
+        <p:spPr>
+          <a:xfrm>
+            <a:off x="502920" y="4660392"/>
+            <a:ext cx="11183112" cy="703326"/>
+          </a:xfrm>
+          <a:prstGeom prst="roundRect">
+            <a:avLst/>
+          </a:prstGeom>
+          <a:solidFill>
+            <a:srgbClr val="F4F7FB"/>
+          </a:solidFill>
+          <a:ln w="12700">
+            <a:solidFill>
+              <a:srgbClr val="E3E8F0"/>
+            </a:solidFill>
+          </a:ln>
+          <a:effectLst/>
+        </p:spPr>
+        <p:style>
+          <a:lnRef idx="1">
+            <a:schemeClr val="accent1"/>
+          </a:lnRef>
+          <a:fillRef idx="3">
+            <a:schemeClr val="accent1"/>
+          </a:fillRef>
+          <a:effectRef idx="2">
+            <a:schemeClr val="accent1"/>
+          </a:effectRef>
+          <a:fontRef idx="minor">
+            <a:schemeClr val="lt1"/>
+          </a:fontRef>
+        </p:style>
+        <p:txBody>
+          <a:bodyPr rtlCol="0" anchor="ctr"/>
+          <a:lstStyle/>
+          <a:p>
+            <a:pPr algn="ctr"/>
+          </a:p>
+        </p:txBody>
+      </p:sp>
+      <p:sp>
+        <p:nvSpPr>
+          <p:cNvPr id="20" name="Rectangle 19"/>
+          <p:cNvSpPr/>
+          <p:nvPr/>
+        </p:nvSpPr>
+        <p:spPr>
+          <a:xfrm>
+            <a:off x="502920" y="4660392"/>
+            <a:ext cx="64008" cy="703326"/>
+          </a:xfrm>
+          <a:prstGeom prst="rect">
+            <a:avLst/>
+          </a:prstGeom>
+          <a:solidFill>
+            <a:srgbClr val="0E9AA7"/>
+          </a:solidFill>
+          <a:ln>
+            <a:noFill/>
+          </a:ln>
+          <a:effectLst/>
+        </p:spPr>
+        <p:style>
+          <a:lnRef idx="1">
+            <a:schemeClr val="accent1"/>
+          </a:lnRef>
+          <a:fillRef idx="3">
+            <a:schemeClr val="accent1"/>
+          </a:fillRef>
+          <a:effectRef idx="2">
+            <a:schemeClr val="accent1"/>
+          </a:effectRef>
+          <a:fontRef idx="minor">
+            <a:schemeClr val="lt1"/>
+          </a:fontRef>
+        </p:style>
+        <p:txBody>
+          <a:bodyPr rtlCol="0" anchor="ctr"/>
+          <a:lstStyle/>
+          <a:p>
+            <a:pPr algn="ctr"/>
+          </a:p>
+        </p:txBody>
+      </p:sp>
+      <p:sp>
+        <p:nvSpPr>
+          <p:cNvPr id="21" name="TextBox 20"/>
           <p:cNvSpPr txBox="1"/>
           <p:nvPr/>
         </p:nvSpPr>
         <p:spPr>
           <a:xfrm>
-            <a:off x="566928" y="3456432"/>
-            <a:ext cx="11064240" cy="438912"/>
+            <a:off x="749808" y="4715256"/>
+            <a:ext cx="10744200" cy="611886"/>
           </a:xfrm>
           <a:prstGeom prst="rect">
             <a:avLst/>
@@ -5559,61 +7247,139 @@
           <a:noFill/>
         </p:spPr>
         <p:txBody>
-          <a:bodyPr wrap="square" lIns="0" rIns="0">
-            <a:spAutoFit/>
-          </a:bodyPr>
-          <a:lstStyle/>
-          <a:p>
-            <a:r>
-              <a:rPr sz="1600" b="1" i="0">
-                <a:solidFill>
-                  <a:srgbClr val="0E9AA7"/>
+          <a:bodyPr wrap="square" lIns="0" rIns="0" tIns="0" bIns="0"/>
+          <a:lstStyle/>
+          <a:p>
+            <a:r>
+              <a:rPr sz="1500" b="1" i="0">
+                <a:solidFill>
+                  <a:srgbClr val="1E2B3A"/>
                 </a:solidFill>
                 <a:latin typeface="Segoe UI"/>
                 <a:ea typeface="Microsoft YaHei"/>
               </a:rPr>
-              <a:t>●  </a:t>
-            </a:r>
-            <a:r>
-              <a:rPr sz="1600" b="1" i="0">
-                <a:solidFill>
-                  <a:srgbClr val="1E2B3A"/>
-                </a:solidFill>
-                <a:latin typeface="Segoe UI"/>
-                <a:ea typeface="Microsoft YaHei"/>
-              </a:rPr>
-              <a:t>Zhao — hold the 18 Aug equipment issue until the nozzles and HTF runs are accepted.  CE document set continues in parallel.</a:t>
+              <a:t>Zhao — hold the 18 Aug equipment issue until nozzles and HTF runs are accepted.</a:t>
             </a:r>
           </a:p>
           <a:p>
             <a:pPr>
               <a:spcBef>
-                <a:spcPts val="100"/>
+                <a:spcPts val="300"/>
               </a:spcBef>
             </a:pPr>
             <a:r>
-              <a:rPr sz="1150" b="0" i="0">
+              <a:rPr sz="1200" b="0" i="0">
                 <a:solidFill>
                   <a:srgbClr val="8A97AB"/>
                 </a:solidFill>
                 <a:latin typeface="Microsoft YaHei"/>
                 <a:ea typeface="Microsoft YaHei"/>
               </a:rPr>
-              <a:t>     赵子亮：管嘴和 HTF 被接受前，不按 8 月 18 日图提采购。CE 资料并行准备。</a:t>
-            </a:r>
-          </a:p>
-        </p:txBody>
-      </p:sp>
-      <p:sp>
-        <p:nvSpPr>
-          <p:cNvPr id="12" name="TextBox 11"/>
+              <a:t>赵子亮：管嘴和 HTF 被接受之前，不按 8 月 18 日的图提采购。</a:t>
+            </a:r>
+          </a:p>
+        </p:txBody>
+      </p:sp>
+      <p:sp>
+        <p:nvSpPr>
+          <p:cNvPr id="22" name="Rounded Rectangle 21"/>
+          <p:cNvSpPr/>
+          <p:nvPr/>
+        </p:nvSpPr>
+        <p:spPr>
+          <a:xfrm>
+            <a:off x="502920" y="5455158"/>
+            <a:ext cx="11183112" cy="703326"/>
+          </a:xfrm>
+          <a:prstGeom prst="roundRect">
+            <a:avLst/>
+          </a:prstGeom>
+          <a:solidFill>
+            <a:srgbClr val="F4F7FB"/>
+          </a:solidFill>
+          <a:ln w="12700">
+            <a:solidFill>
+              <a:srgbClr val="E3E8F0"/>
+            </a:solidFill>
+          </a:ln>
+          <a:effectLst/>
+        </p:spPr>
+        <p:style>
+          <a:lnRef idx="1">
+            <a:schemeClr val="accent1"/>
+          </a:lnRef>
+          <a:fillRef idx="3">
+            <a:schemeClr val="accent1"/>
+          </a:fillRef>
+          <a:effectRef idx="2">
+            <a:schemeClr val="accent1"/>
+          </a:effectRef>
+          <a:fontRef idx="minor">
+            <a:schemeClr val="lt1"/>
+          </a:fontRef>
+        </p:style>
+        <p:txBody>
+          <a:bodyPr rtlCol="0" anchor="ctr"/>
+          <a:lstStyle/>
+          <a:p>
+            <a:pPr algn="ctr"/>
+          </a:p>
+        </p:txBody>
+      </p:sp>
+      <p:sp>
+        <p:nvSpPr>
+          <p:cNvPr id="23" name="Rectangle 22"/>
+          <p:cNvSpPr/>
+          <p:nvPr/>
+        </p:nvSpPr>
+        <p:spPr>
+          <a:xfrm>
+            <a:off x="502920" y="5455158"/>
+            <a:ext cx="64008" cy="703326"/>
+          </a:xfrm>
+          <a:prstGeom prst="rect">
+            <a:avLst/>
+          </a:prstGeom>
+          <a:solidFill>
+            <a:srgbClr val="0E9AA7"/>
+          </a:solidFill>
+          <a:ln>
+            <a:noFill/>
+          </a:ln>
+          <a:effectLst/>
+        </p:spPr>
+        <p:style>
+          <a:lnRef idx="1">
+            <a:schemeClr val="accent1"/>
+          </a:lnRef>
+          <a:fillRef idx="3">
+            <a:schemeClr val="accent1"/>
+          </a:fillRef>
+          <a:effectRef idx="2">
+            <a:schemeClr val="accent1"/>
+          </a:effectRef>
+          <a:fontRef idx="minor">
+            <a:schemeClr val="lt1"/>
+          </a:fontRef>
+        </p:style>
+        <p:txBody>
+          <a:bodyPr rtlCol="0" anchor="ctr"/>
+          <a:lstStyle/>
+          <a:p>
+            <a:pPr algn="ctr"/>
+          </a:p>
+        </p:txBody>
+      </p:sp>
+      <p:sp>
+        <p:nvSpPr>
+          <p:cNvPr id="24" name="TextBox 23"/>
           <p:cNvSpPr txBox="1"/>
           <p:nvPr/>
         </p:nvSpPr>
         <p:spPr>
           <a:xfrm>
-            <a:off x="566928" y="3950208"/>
-            <a:ext cx="11064240" cy="438912"/>
+            <a:off x="749808" y="5510022"/>
+            <a:ext cx="10744200" cy="611886"/>
           </a:xfrm>
           <a:prstGeom prst="rect">
             <a:avLst/>
@@ -5621,54 +7387,42 @@
           <a:noFill/>
         </p:spPr>
         <p:txBody>
-          <a:bodyPr wrap="square" lIns="0" rIns="0">
-            <a:spAutoFit/>
-          </a:bodyPr>
-          <a:lstStyle/>
-          <a:p>
-            <a:r>
-              <a:rPr sz="1600" b="1" i="0">
-                <a:solidFill>
-                  <a:srgbClr val="0E9AA7"/>
+          <a:bodyPr wrap="square" lIns="0" rIns="0" tIns="0" bIns="0"/>
+          <a:lstStyle/>
+          <a:p>
+            <a:r>
+              <a:rPr sz="1500" b="1" i="0">
+                <a:solidFill>
+                  <a:srgbClr val="1E2B3A"/>
                 </a:solidFill>
                 <a:latin typeface="Segoe UI"/>
                 <a:ea typeface="Microsoft YaHei"/>
               </a:rPr>
-              <a:t>●  </a:t>
-            </a:r>
-            <a:r>
-              <a:rPr sz="1600" b="1" i="0">
-                <a:solidFill>
-                  <a:srgbClr val="1E2B3A"/>
-                </a:solidFill>
-                <a:latin typeface="Segoe UI"/>
-                <a:ea typeface="Microsoft YaHei"/>
-              </a:rPr>
-              <a:t>Confirm the visit window with Keith.  Next technical session: 23 Sep, on the same model.</a:t>
+              <a:t>Confirm the visit window with Keith. Next session is 23 Sep, on this model.</a:t>
             </a:r>
           </a:p>
           <a:p>
             <a:pPr>
               <a:spcBef>
-                <a:spcPts val="100"/>
+                <a:spcPts val="300"/>
               </a:spcBef>
             </a:pPr>
             <a:r>
-              <a:rPr sz="1150" b="0" i="0">
+              <a:rPr sz="1200" b="0" i="0">
                 <a:solidFill>
                   <a:srgbClr val="8A97AB"/>
                 </a:solidFill>
                 <a:latin typeface="Microsoft YaHei"/>
                 <a:ea typeface="Microsoft YaHei"/>
               </a:rPr>
-              <a:t>     与 Keith 确认赴英窗口。下一次技术会是 9 月 23 日，仍对着这版模型。</a:t>
-            </a:r>
-          </a:p>
-        </p:txBody>
-      </p:sp>
-      <p:sp>
-        <p:nvSpPr>
-          <p:cNvPr id="13" name="TextBox 12"/>
+              <a:t>与 Keith 确认赴英窗口。9 月 23 日继续对着这版模型讨论。</a:t>
+            </a:r>
+          </a:p>
+        </p:txBody>
+      </p:sp>
+      <p:sp>
+        <p:nvSpPr>
+          <p:cNvPr id="25" name="TextBox 24"/>
           <p:cNvSpPr txBox="1"/>
           <p:nvPr/>
         </p:nvSpPr>
@@ -5703,7 +7457,7 @@
       </p:sp>
       <p:sp>
         <p:nvSpPr>
-          <p:cNvPr id="14" name="TextBox 13"/>
+          <p:cNvPr id="26" name="TextBox 25"/>
           <p:cNvSpPr txBox="1"/>
           <p:nvPr/>
         </p:nvSpPr>
@@ -5732,7 +7486,7 @@
                 <a:latin typeface="Segoe UI"/>
                 <a:ea typeface="Microsoft YaHei"/>
               </a:rPr>
-              <a:t>Bi-weekly Progress 2026-09-09 ~ 09-23    ·    04 / 04</a:t>
+              <a:t>Bi-weekly Progress 2026-09-09 ~ 09-23    ·    05 / 05</a:t>
             </a:r>
           </a:p>
         </p:txBody>

</xml_diff>